<commit_message>
Redraw all equation figures for Chapters 1-4 and Appendix A
Replace the 168 equation figures with one bespoke, formula-computed SCI-PPT figure per equation (editable PPTX plus SVG twin), compact table and symbol spacing, add Chapter 5 and renumber the appendix to 90.

Co-Authored-By: Claude Code <noreply@anthropic.com>
</commit_message>
<xml_diff>
--- a/assets/figures-editable/appendix-studies/a-e01.pptx
+++ b/assets/figures-editable/appendix-studies/a-e01.pptx
@@ -7,7 +7,7 @@
   <p:sldIdLst>
     <p:sldId id="256" r:id="rId7"/>
   </p:sldIdLst>
-  <p:sldSz cx="8961120" cy="5660136" type="screen4x3"/>
+  <p:sldSz cx="12191695" cy="6858000" type="screen4x3"/>
   <p:notesSz cx="6858000" cy="9144000"/>
   <p:defaultTextStyle>
     <a:defPPr>
@@ -3098,14 +3098,14 @@
       <p:grpSpPr/>
       <p:sp>
         <p:nvSpPr>
-          <p:cNvPr id="2" name="text 0" descr="sci-ppt:obj-000"/>
+          <p:cNvPr id="2" name="A-E01 text 0" descr="sci-ppt:o000"/>
           <p:cNvSpPr txBox="1"/>
           <p:nvPr/>
         </p:nvSpPr>
         <p:spPr>
           <a:xfrm>
-            <a:off x="256032" y="137160"/>
-            <a:ext cx="7315200" cy="310896"/>
+            <a:off x="274320" y="118872"/>
+            <a:ext cx="11612880" cy="340105"/>
           </a:xfrm>
           <a:prstGeom prst="rect">
             <a:avLst/>
@@ -3114,7 +3114,7 @@
           <a:effectLst/>
         </p:spPr>
         <p:txBody>
-          <a:bodyPr wrap="none" lIns="0" rIns="0" tIns="0" bIns="0" anchor="ctr">
+          <a:bodyPr wrap="none" lIns="18288" rIns="18288" tIns="18288" bIns="18288" anchor="t">
             <a:spAutoFit/>
           </a:bodyPr>
           <a:lstStyle/>
@@ -3125,63 +3125,105 @@
               </a:spcAft>
             </a:pPr>
             <a:r>
-              <a:rPr sz="1439" b="0" i="0">
+              <a:rPr sz="1900" b="1" i="0">
                 <a:solidFill>
                   <a:srgbClr val="8EDBD4"/>
                 </a:solidFill>
                 <a:latin typeface="Arial"/>
               </a:rPr>
-              <a:t>A-E01 · Physical variable map</a:t>
-            </a:r>
-          </a:p>
-        </p:txBody>
-      </p:sp>
-      <p:sp>
-        <p:nvSpPr>
-          <p:cNvPr id="3" name="ellipse 1" descr="sci-ppt:obj-001"/>
+              <a:t>A-E01 · Exact kinematics under incompressibility</a:t>
+            </a:r>
+          </a:p>
+        </p:txBody>
+      </p:sp>
+      <p:sp>
+        <p:nvSpPr>
+          <p:cNvPr id="3" name="A-E01 round_rect 1" descr="sci-ppt:o001"/>
           <p:cNvSpPr/>
           <p:nvPr/>
         </p:nvSpPr>
         <p:spPr>
           <a:xfrm>
-            <a:off x="1060704" y="914400"/>
-            <a:ext cx="1463040" cy="1463040"/>
-          </a:xfrm>
-          <a:prstGeom prst="ellipse">
+            <a:off x="365760" y="914400"/>
+            <a:ext cx="4937760" cy="4846320"/>
+          </a:xfrm>
+          <a:prstGeom prst="roundRect">
+            <a:avLst/>
+          </a:prstGeom>
+          <a:solidFill>
+            <a:srgbClr val="213E4B"/>
+          </a:solidFill>
+          <a:ln w="20320">
+            <a:solidFill>
+              <a:srgbClr val="8EDBD4"/>
+            </a:solidFill>
+          </a:ln>
+          <a:effectLst/>
+        </p:spPr>
+        <p:txBody>
+          <a:bodyPr rtlCol="0" anchor="ctr"/>
+          <a:lstStyle/>
+          <a:p>
+            <a:pPr algn="ctr"/>
+          </a:p>
+        </p:txBody>
+      </p:sp>
+      <p:sp>
+        <p:nvSpPr>
+          <p:cNvPr id="4" name="A-E01 text 2" descr="sci-ppt:o002"/>
+          <p:cNvSpPr txBox="1"/>
+          <p:nvPr/>
+        </p:nvSpPr>
+        <p:spPr>
+          <a:xfrm>
+            <a:off x="475488" y="969264"/>
+            <a:ext cx="4718304" cy="254889"/>
+          </a:xfrm>
+          <a:prstGeom prst="rect">
             <a:avLst/>
           </a:prstGeom>
           <a:noFill/>
-          <a:ln w="17780">
-            <a:solidFill>
-              <a:srgbClr val="B4C7D2"/>
-            </a:solidFill>
-          </a:ln>
           <a:effectLst/>
         </p:spPr>
         <p:txBody>
-          <a:bodyPr rtlCol="0" anchor="ctr"/>
-          <a:lstStyle/>
-          <a:p>
-            <a:pPr algn="ctr"/>
-          </a:p>
-        </p:txBody>
-      </p:sp>
-      <p:sp>
-        <p:nvSpPr>
-          <p:cNvPr id="4" name="ellipse 2" descr="sci-ppt:obj-002"/>
+          <a:bodyPr wrap="none" lIns="18288" rIns="18288" tIns="18288" bIns="18288" anchor="t">
+            <a:spAutoFit/>
+          </a:bodyPr>
+          <a:lstStyle/>
+          <a:p>
+            <a:pPr algn="l">
+              <a:spcAft>
+                <a:spcPts val="0"/>
+              </a:spcAft>
+            </a:pPr>
+            <a:r>
+              <a:rPr sz="1350" b="1" i="0">
+                <a:solidFill>
+                  <a:srgbClr val="8EDBD4"/>
+                </a:solidFill>
+                <a:latin typeface="Arial"/>
+              </a:rPr>
+              <a:t>The same network shells before and after</a:t>
+            </a:r>
+          </a:p>
+        </p:txBody>
+      </p:sp>
+      <p:sp>
+        <p:nvSpPr>
+          <p:cNvPr id="5" name="A-E01 ellipse 3" descr="sci-ppt:o003"/>
           <p:cNvSpPr/>
           <p:nvPr/>
         </p:nvSpPr>
         <p:spPr>
           <a:xfrm>
-            <a:off x="1463040" y="1316736"/>
-            <a:ext cx="658368" cy="658368"/>
+            <a:off x="1005840" y="2468880"/>
+            <a:ext cx="731520" cy="731520"/>
           </a:xfrm>
           <a:prstGeom prst="ellipse">
             <a:avLst/>
           </a:prstGeom>
           <a:solidFill>
-            <a:srgbClr val="213E4B"/>
+            <a:srgbClr val="0C1820"/>
           </a:solidFill>
           <a:ln w="17780">
             <a:solidFill>
@@ -3198,21 +3240,253 @@
           </a:p>
         </p:txBody>
       </p:sp>
+      <p:sp>
+        <p:nvSpPr>
+          <p:cNvPr id="6" name="A-E01 text 4" descr="sci-ppt:o004"/>
+          <p:cNvSpPr txBox="1"/>
+          <p:nvPr/>
+        </p:nvSpPr>
+        <p:spPr>
+          <a:xfrm>
+            <a:off x="822960" y="2697480"/>
+            <a:ext cx="1097280" cy="208407"/>
+          </a:xfrm>
+          <a:prstGeom prst="rect">
+            <a:avLst/>
+          </a:prstGeom>
+          <a:noFill/>
+          <a:effectLst/>
+        </p:spPr>
+        <p:txBody>
+          <a:bodyPr wrap="none" lIns="18288" rIns="18288" tIns="18288" bIns="18288" anchor="t">
+            <a:spAutoFit/>
+          </a:bodyPr>
+          <a:lstStyle/>
+          <a:p>
+            <a:pPr algn="ctr">
+              <a:spcAft>
+                <a:spcPts val="0"/>
+              </a:spcAft>
+            </a:pPr>
+            <a:r>
+              <a:rPr sz="1050" b="0" i="0">
+                <a:solidFill>
+                  <a:srgbClr val="B4C7D2"/>
+                </a:solidFill>
+                <a:latin typeface="Arial"/>
+              </a:rPr>
+              <a:t>R_ref</a:t>
+            </a:r>
+          </a:p>
+        </p:txBody>
+      </p:sp>
+      <p:sp>
+        <p:nvSpPr>
+          <p:cNvPr id="7" name="A-E01 ellipse 5" descr="sci-ppt:o005"/>
+          <p:cNvSpPr/>
+          <p:nvPr/>
+        </p:nvSpPr>
+        <p:spPr>
+          <a:xfrm>
+            <a:off x="777240" y="2240280"/>
+            <a:ext cx="1188720" cy="1188720"/>
+          </a:xfrm>
+          <a:prstGeom prst="ellipse">
+            <a:avLst/>
+          </a:prstGeom>
+          <a:noFill/>
+          <a:ln w="13970">
+            <a:solidFill>
+              <a:srgbClr val="2B6678"/>
+            </a:solidFill>
+          </a:ln>
+          <a:effectLst/>
+        </p:spPr>
+        <p:txBody>
+          <a:bodyPr rtlCol="0" anchor="ctr"/>
+          <a:lstStyle/>
+          <a:p>
+            <a:pPr algn="ctr"/>
+          </a:p>
+        </p:txBody>
+      </p:sp>
+      <p:sp>
+        <p:nvSpPr>
+          <p:cNvPr id="8" name="A-E01 ellipse 6" descr="sci-ppt:o006"/>
+          <p:cNvSpPr/>
+          <p:nvPr/>
+        </p:nvSpPr>
+        <p:spPr>
+          <a:xfrm>
+            <a:off x="548640" y="2011680"/>
+            <a:ext cx="1645920" cy="1645920"/>
+          </a:xfrm>
+          <a:prstGeom prst="ellipse">
+            <a:avLst/>
+          </a:prstGeom>
+          <a:noFill/>
+          <a:ln w="13970">
+            <a:solidFill>
+              <a:srgbClr val="2B6678"/>
+            </a:solidFill>
+          </a:ln>
+          <a:effectLst/>
+        </p:spPr>
+        <p:txBody>
+          <a:bodyPr rtlCol="0" anchor="ctr"/>
+          <a:lstStyle/>
+          <a:p>
+            <a:pPr algn="ctr"/>
+          </a:p>
+        </p:txBody>
+      </p:sp>
+      <p:sp>
+        <p:nvSpPr>
+          <p:cNvPr id="9" name="A-E01 text 7" descr="sci-ppt:o007"/>
+          <p:cNvSpPr txBox="1"/>
+          <p:nvPr/>
+        </p:nvSpPr>
+        <p:spPr>
+          <a:xfrm>
+            <a:off x="548640" y="4069080"/>
+            <a:ext cx="2194560" cy="223900"/>
+          </a:xfrm>
+          <a:prstGeom prst="rect">
+            <a:avLst/>
+          </a:prstGeom>
+          <a:noFill/>
+          <a:effectLst/>
+        </p:spPr>
+        <p:txBody>
+          <a:bodyPr wrap="none" lIns="18288" rIns="18288" tIns="18288" bIns="18288" anchor="t">
+            <a:spAutoFit/>
+          </a:bodyPr>
+          <a:lstStyle/>
+          <a:p>
+            <a:pPr algn="l">
+              <a:spcAft>
+                <a:spcPts val="0"/>
+              </a:spcAft>
+            </a:pPr>
+            <a:r>
+              <a:rPr sz="1150" b="0" i="0">
+                <a:solidFill>
+                  <a:srgbClr val="B4C7D2"/>
+                </a:solidFill>
+                <a:latin typeface="Arial"/>
+              </a:rPr>
+              <a:t>reference state</a:t>
+            </a:r>
+          </a:p>
+        </p:txBody>
+      </p:sp>
+      <p:sp>
+        <p:nvSpPr>
+          <p:cNvPr id="10" name="A-E01 ellipse 8" descr="sci-ppt:o008"/>
+          <p:cNvSpPr/>
+          <p:nvPr/>
+        </p:nvSpPr>
+        <p:spPr>
+          <a:xfrm>
+            <a:off x="3108960" y="2103120"/>
+            <a:ext cx="1463040" cy="1463040"/>
+          </a:xfrm>
+          <a:prstGeom prst="ellipse">
+            <a:avLst/>
+          </a:prstGeom>
+          <a:solidFill>
+            <a:srgbClr val="0C1820"/>
+          </a:solidFill>
+          <a:ln w="27940">
+            <a:solidFill>
+              <a:srgbClr val="F2B880"/>
+            </a:solidFill>
+          </a:ln>
+          <a:effectLst/>
+        </p:spPr>
+        <p:txBody>
+          <a:bodyPr rtlCol="0" anchor="ctr"/>
+          <a:lstStyle/>
+          <a:p>
+            <a:pPr algn="ctr"/>
+          </a:p>
+        </p:txBody>
+      </p:sp>
+      <p:sp>
+        <p:nvSpPr>
+          <p:cNvPr id="11" name="A-E01 ellipse 9" descr="sci-ppt:o009"/>
+          <p:cNvSpPr/>
+          <p:nvPr/>
+        </p:nvSpPr>
+        <p:spPr>
+          <a:xfrm>
+            <a:off x="2926080" y="1920240"/>
+            <a:ext cx="1828800" cy="1828800"/>
+          </a:xfrm>
+          <a:prstGeom prst="ellipse">
+            <a:avLst/>
+          </a:prstGeom>
+          <a:noFill/>
+          <a:ln w="13970">
+            <a:solidFill>
+              <a:srgbClr val="2B6678"/>
+            </a:solidFill>
+          </a:ln>
+          <a:effectLst/>
+        </p:spPr>
+        <p:txBody>
+          <a:bodyPr rtlCol="0" anchor="ctr"/>
+          <a:lstStyle/>
+          <a:p>
+            <a:pPr algn="ctr"/>
+          </a:p>
+        </p:txBody>
+      </p:sp>
+      <p:sp>
+        <p:nvSpPr>
+          <p:cNvPr id="12" name="A-E01 ellipse 10" descr="sci-ppt:o010"/>
+          <p:cNvSpPr/>
+          <p:nvPr/>
+        </p:nvSpPr>
+        <p:spPr>
+          <a:xfrm>
+            <a:off x="2743200" y="1737360"/>
+            <a:ext cx="2194560" cy="2194560"/>
+          </a:xfrm>
+          <a:prstGeom prst="ellipse">
+            <a:avLst/>
+          </a:prstGeom>
+          <a:noFill/>
+          <a:ln w="13970">
+            <a:solidFill>
+              <a:srgbClr val="2B6678"/>
+            </a:solidFill>
+          </a:ln>
+          <a:effectLst/>
+        </p:spPr>
+        <p:txBody>
+          <a:bodyPr rtlCol="0" anchor="ctr"/>
+          <a:lstStyle/>
+          <a:p>
+            <a:pPr algn="ctr"/>
+          </a:p>
+        </p:txBody>
+      </p:sp>
       <p:cxnSp>
         <p:nvCxnSpPr>
-          <p:cNvPr id="5" name="arrow 3" descr="sci-ppt:obj-003"/>
+          <p:cNvPr id="13" name="A-E01 arrow 11" descr="sci-ppt:o011"/>
           <p:cNvCxnSpPr/>
           <p:nvPr/>
         </p:nvCxnSpPr>
         <p:spPr>
           <a:xfrm>
-            <a:off x="1792224" y="1645920"/>
-            <a:ext cx="329184" cy="0"/>
+            <a:off x="2103120" y="2834640"/>
+            <a:ext cx="640080" cy="0"/>
           </a:xfrm>
           <a:prstGeom prst="line">
             <a:avLst/>
           </a:prstGeom>
-          <a:ln w="21590">
+          <a:ln w="38100">
             <a:solidFill>
               <a:srgbClr val="8EDBD4"/>
             </a:solidFill>
@@ -3224,14 +3498,14 @@
       </p:cxnSp>
       <p:sp>
         <p:nvSpPr>
-          <p:cNvPr id="6" name="text 4" descr="sci-ppt:obj-004"/>
+          <p:cNvPr id="14" name="A-E01 text 12" descr="sci-ppt:o012"/>
           <p:cNvSpPr txBox="1"/>
           <p:nvPr/>
         </p:nvSpPr>
         <p:spPr>
           <a:xfrm>
-            <a:off x="1755648" y="1271016"/>
-            <a:ext cx="1097280" cy="310896"/>
+            <a:off x="3383280" y="2697480"/>
+            <a:ext cx="914400" cy="231648"/>
           </a:xfrm>
           <a:prstGeom prst="rect">
             <a:avLst/>
@@ -3240,7 +3514,47 @@
           <a:effectLst/>
         </p:spPr>
         <p:txBody>
-          <a:bodyPr wrap="none" lIns="0" rIns="0" tIns="0" bIns="0" anchor="ctr">
+          <a:bodyPr wrap="none" lIns="18288" rIns="18288" tIns="18288" bIns="18288" anchor="t">
+            <a:spAutoFit/>
+          </a:bodyPr>
+          <a:lstStyle/>
+          <a:p>
+            <a:pPr algn="ctr">
+              <a:spcAft>
+                <a:spcPts val="0"/>
+              </a:spcAft>
+            </a:pPr>
+            <a:r>
+              <a:rPr sz="1200" b="1" i="0">
+                <a:solidFill>
+                  <a:srgbClr val="F2B880"/>
+                </a:solidFill>
+                <a:latin typeface="Arial"/>
+              </a:rPr>
+              <a:t>R</a:t>
+            </a:r>
+          </a:p>
+        </p:txBody>
+      </p:sp>
+      <p:sp>
+        <p:nvSpPr>
+          <p:cNvPr id="15" name="A-E01 text 13" descr="sci-ppt:o013"/>
+          <p:cNvSpPr txBox="1"/>
+          <p:nvPr/>
+        </p:nvSpPr>
+        <p:spPr>
+          <a:xfrm>
+            <a:off x="2743200" y="4069080"/>
+            <a:ext cx="2377440" cy="223900"/>
+          </a:xfrm>
+          <a:prstGeom prst="rect">
+            <a:avLst/>
+          </a:prstGeom>
+          <a:noFill/>
+          <a:effectLst/>
+        </p:spPr>
+        <p:txBody>
+          <a:bodyPr wrap="none" lIns="18288" rIns="18288" tIns="18288" bIns="18288" anchor="t">
             <a:spAutoFit/>
           </a:bodyPr>
           <a:lstStyle/>
@@ -3251,51 +3565,67 @@
               </a:spcAft>
             </a:pPr>
             <a:r>
-              <a:rPr sz="1296" b="0" i="0">
+              <a:rPr sz="1150" b="0" i="0">
+                <a:solidFill>
+                  <a:srgbClr val="F2B880"/>
+                </a:solidFill>
+                <a:latin typeface="Arial"/>
+              </a:rPr>
+              <a:t>expanded to R</a:t>
+            </a:r>
+          </a:p>
+        </p:txBody>
+      </p:sp>
+      <p:sp>
+        <p:nvSpPr>
+          <p:cNvPr id="16" name="A-E01 text 14" descr="sci-ppt:o014"/>
+          <p:cNvSpPr txBox="1"/>
+          <p:nvPr/>
+        </p:nvSpPr>
+        <p:spPr>
+          <a:xfrm>
+            <a:off x="548640" y="4434840"/>
+            <a:ext cx="4572000" cy="231648"/>
+          </a:xfrm>
+          <a:prstGeom prst="rect">
+            <a:avLst/>
+          </a:prstGeom>
+          <a:noFill/>
+          <a:effectLst/>
+        </p:spPr>
+        <p:txBody>
+          <a:bodyPr wrap="none" lIns="18288" rIns="18288" tIns="18288" bIns="18288" anchor="t">
+            <a:spAutoFit/>
+          </a:bodyPr>
+          <a:lstStyle/>
+          <a:p>
+            <a:pPr algn="l">
+              <a:spcAft>
+                <a:spcPts val="0"/>
+              </a:spcAft>
+            </a:pPr>
+            <a:r>
+              <a:rPr sz="1200" b="1" i="0">
                 <a:solidFill>
                   <a:srgbClr val="E7F0F3"/>
                 </a:solidFill>
                 <a:latin typeface="Arial"/>
               </a:rPr>
-              <a:t>Rref</a:t>
-            </a:r>
-          </a:p>
-        </p:txBody>
-      </p:sp>
-      <p:cxnSp>
-        <p:nvCxnSpPr>
-          <p:cNvPr id="7" name="arrow 5" descr="sci-ppt:obj-005"/>
-          <p:cNvCxnSpPr/>
-          <p:nvPr/>
-        </p:nvCxnSpPr>
-        <p:spPr>
-          <a:xfrm>
-            <a:off x="1792224" y="1645920"/>
-            <a:ext cx="517262" cy="517262"/>
-          </a:xfrm>
-          <a:prstGeom prst="line">
-            <a:avLst/>
-          </a:prstGeom>
-          <a:ln w="21590">
-            <a:solidFill>
-              <a:srgbClr val="8EDBD4"/>
-            </a:solidFill>
-            <a:headEnd type="none" w="med" len="med"/>
-            <a:tailEnd type="triangle" w="med" len="med"/>
-          </a:ln>
-          <a:effectLst/>
-        </p:spPr>
-      </p:cxnSp>
-      <p:sp>
-        <p:nvSpPr>
-          <p:cNvPr id="8" name="text 6" descr="sci-ppt:obj-006"/>
+              <a:t>shell volume conserved: r³ − R³ = r₀³ − R_ref³</a:t>
+            </a:r>
+          </a:p>
+        </p:txBody>
+      </p:sp>
+      <p:sp>
+        <p:nvSpPr>
+          <p:cNvPr id="17" name="A-E01 text 15" descr="sci-ppt:o015"/>
           <p:cNvSpPr txBox="1"/>
           <p:nvPr/>
         </p:nvSpPr>
         <p:spPr>
           <a:xfrm>
-            <a:off x="2304288" y="2139696"/>
-            <a:ext cx="822960" cy="310896"/>
+            <a:off x="548640" y="4937760"/>
+            <a:ext cx="4572000" cy="223900"/>
           </a:xfrm>
           <a:prstGeom prst="rect">
             <a:avLst/>
@@ -3304,7 +3634,7 @@
           <a:effectLst/>
         </p:spPr>
         <p:txBody>
-          <a:bodyPr wrap="none" lIns="0" rIns="0" tIns="0" bIns="0" anchor="ctr">
+          <a:bodyPr wrap="none" lIns="18288" rIns="18288" tIns="18288" bIns="18288" anchor="t">
             <a:spAutoFit/>
           </a:bodyPr>
           <a:lstStyle/>
@@ -3315,113 +3645,1141 @@
               </a:spcAft>
             </a:pPr>
             <a:r>
-              <a:rPr sz="1296" b="0" i="0">
+              <a:rPr sz="1150" b="1" i="0">
+                <a:solidFill>
+                  <a:srgbClr val="F2B880"/>
+                </a:solidFill>
+                <a:latin typeface="Arial"/>
+              </a:rPr>
+              <a:t>λᵣ = ∂r/∂r₀ = r₀²/r²,   λ_θ = λᵩ = r/r₀,   λ_rλ_θλᵩ = 1</a:t>
+            </a:r>
+          </a:p>
+        </p:txBody>
+      </p:sp>
+      <p:cxnSp>
+        <p:nvCxnSpPr>
+          <p:cNvPr id="18" name="A-E01 line 16" descr="sci-ppt:o016"/>
+          <p:cNvCxnSpPr/>
+          <p:nvPr/>
+        </p:nvCxnSpPr>
+        <p:spPr>
+          <a:xfrm>
+            <a:off x="6126480" y="5029200"/>
+            <a:ext cx="5577840" cy="0"/>
+          </a:xfrm>
+          <a:prstGeom prst="line">
+            <a:avLst/>
+          </a:prstGeom>
+          <a:ln w="19050">
+            <a:solidFill>
+              <a:srgbClr val="B4C7D2"/>
+            </a:solidFill>
+          </a:ln>
+          <a:effectLst/>
+        </p:spPr>
+      </p:cxnSp>
+      <p:cxnSp>
+        <p:nvCxnSpPr>
+          <p:cNvPr id="19" name="A-E01 line 17" descr="sci-ppt:o017"/>
+          <p:cNvCxnSpPr/>
+          <p:nvPr/>
+        </p:nvCxnSpPr>
+        <p:spPr>
+          <a:xfrm>
+            <a:off x="6126480" y="1371600"/>
+            <a:ext cx="0" cy="3657600"/>
+          </a:xfrm>
+          <a:prstGeom prst="line">
+            <a:avLst/>
+          </a:prstGeom>
+          <a:ln w="19050">
+            <a:solidFill>
+              <a:srgbClr val="B4C7D2"/>
+            </a:solidFill>
+          </a:ln>
+          <a:effectLst/>
+        </p:spPr>
+      </p:cxnSp>
+      <p:cxnSp>
+        <p:nvCxnSpPr>
+          <p:cNvPr id="20" name="A-E01 line 18" descr="sci-ppt:o018"/>
+          <p:cNvCxnSpPr/>
+          <p:nvPr/>
+        </p:nvCxnSpPr>
+        <p:spPr>
+          <a:xfrm>
+            <a:off x="6126480" y="5029200"/>
+            <a:ext cx="0" cy="64008"/>
+          </a:xfrm>
+          <a:prstGeom prst="line">
+            <a:avLst/>
+          </a:prstGeom>
+          <a:ln w="12700">
+            <a:solidFill>
+              <a:srgbClr val="B4C7D2"/>
+            </a:solidFill>
+          </a:ln>
+          <a:effectLst/>
+        </p:spPr>
+      </p:cxnSp>
+      <p:cxnSp>
+        <p:nvCxnSpPr>
+          <p:cNvPr id="21" name="A-E01 line 19" descr="sci-ppt:o019"/>
+          <p:cNvCxnSpPr/>
+          <p:nvPr/>
+        </p:nvCxnSpPr>
+        <p:spPr>
+          <a:xfrm>
+            <a:off x="6126480" y="1371600"/>
+            <a:ext cx="0" cy="3657600"/>
+          </a:xfrm>
+          <a:prstGeom prst="line">
+            <a:avLst/>
+          </a:prstGeom>
+          <a:ln w="7620">
+            <a:solidFill>
+              <a:srgbClr val="2E4756"/>
+            </a:solidFill>
+          </a:ln>
+          <a:effectLst/>
+        </p:spPr>
+      </p:cxnSp>
+      <p:sp>
+        <p:nvSpPr>
+          <p:cNvPr id="22" name="A-E01 text 20" descr="sci-ppt:o020"/>
+          <p:cNvSpPr txBox="1"/>
+          <p:nvPr/>
+        </p:nvSpPr>
+        <p:spPr>
+          <a:xfrm>
+            <a:off x="5669280" y="5111496"/>
+            <a:ext cx="914400" cy="208407"/>
+          </a:xfrm>
+          <a:prstGeom prst="rect">
+            <a:avLst/>
+          </a:prstGeom>
+          <a:noFill/>
+          <a:effectLst/>
+        </p:spPr>
+        <p:txBody>
+          <a:bodyPr wrap="none" lIns="18288" rIns="18288" tIns="18288" bIns="18288" anchor="t">
+            <a:spAutoFit/>
+          </a:bodyPr>
+          <a:lstStyle/>
+          <a:p>
+            <a:pPr algn="ctr">
+              <a:spcAft>
+                <a:spcPts val="0"/>
+              </a:spcAft>
+            </a:pPr>
+            <a:r>
+              <a:rPr sz="1050" b="0" i="0">
+                <a:solidFill>
+                  <a:srgbClr val="B4C7D2"/>
+                </a:solidFill>
+                <a:latin typeface="Arial"/>
+              </a:rPr>
+              <a:t>1</a:t>
+            </a:r>
+          </a:p>
+        </p:txBody>
+      </p:sp>
+      <p:cxnSp>
+        <p:nvCxnSpPr>
+          <p:cNvPr id="23" name="A-E01 line 21" descr="sci-ppt:o021"/>
+          <p:cNvCxnSpPr/>
+          <p:nvPr/>
+        </p:nvCxnSpPr>
+        <p:spPr>
+          <a:xfrm>
+            <a:off x="7242048" y="5029200"/>
+            <a:ext cx="0" cy="64008"/>
+          </a:xfrm>
+          <a:prstGeom prst="line">
+            <a:avLst/>
+          </a:prstGeom>
+          <a:ln w="12700">
+            <a:solidFill>
+              <a:srgbClr val="B4C7D2"/>
+            </a:solidFill>
+          </a:ln>
+          <a:effectLst/>
+        </p:spPr>
+      </p:cxnSp>
+      <p:cxnSp>
+        <p:nvCxnSpPr>
+          <p:cNvPr id="24" name="A-E01 line 22" descr="sci-ppt:o022"/>
+          <p:cNvCxnSpPr/>
+          <p:nvPr/>
+        </p:nvCxnSpPr>
+        <p:spPr>
+          <a:xfrm>
+            <a:off x="7242048" y="1371600"/>
+            <a:ext cx="0" cy="3657600"/>
+          </a:xfrm>
+          <a:prstGeom prst="line">
+            <a:avLst/>
+          </a:prstGeom>
+          <a:ln w="7620">
+            <a:solidFill>
+              <a:srgbClr val="2E4756"/>
+            </a:solidFill>
+          </a:ln>
+          <a:effectLst/>
+        </p:spPr>
+      </p:cxnSp>
+      <p:sp>
+        <p:nvSpPr>
+          <p:cNvPr id="25" name="A-E01 text 23" descr="sci-ppt:o023"/>
+          <p:cNvSpPr txBox="1"/>
+          <p:nvPr/>
+        </p:nvSpPr>
+        <p:spPr>
+          <a:xfrm>
+            <a:off x="6784848" y="5111496"/>
+            <a:ext cx="914400" cy="208407"/>
+          </a:xfrm>
+          <a:prstGeom prst="rect">
+            <a:avLst/>
+          </a:prstGeom>
+          <a:noFill/>
+          <a:effectLst/>
+        </p:spPr>
+        <p:txBody>
+          <a:bodyPr wrap="none" lIns="18288" rIns="18288" tIns="18288" bIns="18288" anchor="t">
+            <a:spAutoFit/>
+          </a:bodyPr>
+          <a:lstStyle/>
+          <a:p>
+            <a:pPr algn="ctr">
+              <a:spcAft>
+                <a:spcPts val="0"/>
+              </a:spcAft>
+            </a:pPr>
+            <a:r>
+              <a:rPr sz="1050" b="0" i="0">
+                <a:solidFill>
+                  <a:srgbClr val="B4C7D2"/>
+                </a:solidFill>
+                <a:latin typeface="Arial"/>
+              </a:rPr>
+              <a:t>2</a:t>
+            </a:r>
+          </a:p>
+        </p:txBody>
+      </p:sp>
+      <p:cxnSp>
+        <p:nvCxnSpPr>
+          <p:cNvPr id="26" name="A-E01 line 24" descr="sci-ppt:o024"/>
+          <p:cNvCxnSpPr/>
+          <p:nvPr/>
+        </p:nvCxnSpPr>
+        <p:spPr>
+          <a:xfrm>
+            <a:off x="8357616" y="5029200"/>
+            <a:ext cx="0" cy="64008"/>
+          </a:xfrm>
+          <a:prstGeom prst="line">
+            <a:avLst/>
+          </a:prstGeom>
+          <a:ln w="12700">
+            <a:solidFill>
+              <a:srgbClr val="B4C7D2"/>
+            </a:solidFill>
+          </a:ln>
+          <a:effectLst/>
+        </p:spPr>
+      </p:cxnSp>
+      <p:cxnSp>
+        <p:nvCxnSpPr>
+          <p:cNvPr id="27" name="A-E01 line 25" descr="sci-ppt:o025"/>
+          <p:cNvCxnSpPr/>
+          <p:nvPr/>
+        </p:nvCxnSpPr>
+        <p:spPr>
+          <a:xfrm>
+            <a:off x="8357616" y="1371600"/>
+            <a:ext cx="0" cy="3657600"/>
+          </a:xfrm>
+          <a:prstGeom prst="line">
+            <a:avLst/>
+          </a:prstGeom>
+          <a:ln w="7620">
+            <a:solidFill>
+              <a:srgbClr val="2E4756"/>
+            </a:solidFill>
+          </a:ln>
+          <a:effectLst/>
+        </p:spPr>
+      </p:cxnSp>
+      <p:sp>
+        <p:nvSpPr>
+          <p:cNvPr id="28" name="A-E01 text 26" descr="sci-ppt:o026"/>
+          <p:cNvSpPr txBox="1"/>
+          <p:nvPr/>
+        </p:nvSpPr>
+        <p:spPr>
+          <a:xfrm>
+            <a:off x="7900416" y="5111496"/>
+            <a:ext cx="914400" cy="208407"/>
+          </a:xfrm>
+          <a:prstGeom prst="rect">
+            <a:avLst/>
+          </a:prstGeom>
+          <a:noFill/>
+          <a:effectLst/>
+        </p:spPr>
+        <p:txBody>
+          <a:bodyPr wrap="none" lIns="18288" rIns="18288" tIns="18288" bIns="18288" anchor="t">
+            <a:spAutoFit/>
+          </a:bodyPr>
+          <a:lstStyle/>
+          <a:p>
+            <a:pPr algn="ctr">
+              <a:spcAft>
+                <a:spcPts val="0"/>
+              </a:spcAft>
+            </a:pPr>
+            <a:r>
+              <a:rPr sz="1050" b="0" i="0">
+                <a:solidFill>
+                  <a:srgbClr val="B4C7D2"/>
+                </a:solidFill>
+                <a:latin typeface="Arial"/>
+              </a:rPr>
+              <a:t>3</a:t>
+            </a:r>
+          </a:p>
+        </p:txBody>
+      </p:sp>
+      <p:cxnSp>
+        <p:nvCxnSpPr>
+          <p:cNvPr id="29" name="A-E01 line 27" descr="sci-ppt:o027"/>
+          <p:cNvCxnSpPr/>
+          <p:nvPr/>
+        </p:nvCxnSpPr>
+        <p:spPr>
+          <a:xfrm>
+            <a:off x="9473184" y="5029200"/>
+            <a:ext cx="0" cy="64008"/>
+          </a:xfrm>
+          <a:prstGeom prst="line">
+            <a:avLst/>
+          </a:prstGeom>
+          <a:ln w="12700">
+            <a:solidFill>
+              <a:srgbClr val="B4C7D2"/>
+            </a:solidFill>
+          </a:ln>
+          <a:effectLst/>
+        </p:spPr>
+      </p:cxnSp>
+      <p:cxnSp>
+        <p:nvCxnSpPr>
+          <p:cNvPr id="30" name="A-E01 line 28" descr="sci-ppt:o028"/>
+          <p:cNvCxnSpPr/>
+          <p:nvPr/>
+        </p:nvCxnSpPr>
+        <p:spPr>
+          <a:xfrm>
+            <a:off x="9473184" y="1371600"/>
+            <a:ext cx="0" cy="3657600"/>
+          </a:xfrm>
+          <a:prstGeom prst="line">
+            <a:avLst/>
+          </a:prstGeom>
+          <a:ln w="7620">
+            <a:solidFill>
+              <a:srgbClr val="2E4756"/>
+            </a:solidFill>
+          </a:ln>
+          <a:effectLst/>
+        </p:spPr>
+      </p:cxnSp>
+      <p:sp>
+        <p:nvSpPr>
+          <p:cNvPr id="31" name="A-E01 text 29" descr="sci-ppt:o029"/>
+          <p:cNvSpPr txBox="1"/>
+          <p:nvPr/>
+        </p:nvSpPr>
+        <p:spPr>
+          <a:xfrm>
+            <a:off x="9015984" y="5111496"/>
+            <a:ext cx="914400" cy="208407"/>
+          </a:xfrm>
+          <a:prstGeom prst="rect">
+            <a:avLst/>
+          </a:prstGeom>
+          <a:noFill/>
+          <a:effectLst/>
+        </p:spPr>
+        <p:txBody>
+          <a:bodyPr wrap="none" lIns="18288" rIns="18288" tIns="18288" bIns="18288" anchor="t">
+            <a:spAutoFit/>
+          </a:bodyPr>
+          <a:lstStyle/>
+          <a:p>
+            <a:pPr algn="ctr">
+              <a:spcAft>
+                <a:spcPts val="0"/>
+              </a:spcAft>
+            </a:pPr>
+            <a:r>
+              <a:rPr sz="1050" b="0" i="0">
+                <a:solidFill>
+                  <a:srgbClr val="B4C7D2"/>
+                </a:solidFill>
+                <a:latin typeface="Arial"/>
+              </a:rPr>
+              <a:t>4</a:t>
+            </a:r>
+          </a:p>
+        </p:txBody>
+      </p:sp>
+      <p:cxnSp>
+        <p:nvCxnSpPr>
+          <p:cNvPr id="32" name="A-E01 line 30" descr="sci-ppt:o030"/>
+          <p:cNvCxnSpPr/>
+          <p:nvPr/>
+        </p:nvCxnSpPr>
+        <p:spPr>
+          <a:xfrm>
+            <a:off x="10588752" y="5029200"/>
+            <a:ext cx="0" cy="64008"/>
+          </a:xfrm>
+          <a:prstGeom prst="line">
+            <a:avLst/>
+          </a:prstGeom>
+          <a:ln w="12700">
+            <a:solidFill>
+              <a:srgbClr val="B4C7D2"/>
+            </a:solidFill>
+          </a:ln>
+          <a:effectLst/>
+        </p:spPr>
+      </p:cxnSp>
+      <p:cxnSp>
+        <p:nvCxnSpPr>
+          <p:cNvPr id="33" name="A-E01 line 31" descr="sci-ppt:o031"/>
+          <p:cNvCxnSpPr/>
+          <p:nvPr/>
+        </p:nvCxnSpPr>
+        <p:spPr>
+          <a:xfrm>
+            <a:off x="10588752" y="1371600"/>
+            <a:ext cx="0" cy="3657600"/>
+          </a:xfrm>
+          <a:prstGeom prst="line">
+            <a:avLst/>
+          </a:prstGeom>
+          <a:ln w="7620">
+            <a:solidFill>
+              <a:srgbClr val="2E4756"/>
+            </a:solidFill>
+          </a:ln>
+          <a:effectLst/>
+        </p:spPr>
+      </p:cxnSp>
+      <p:sp>
+        <p:nvSpPr>
+          <p:cNvPr id="34" name="A-E01 text 32" descr="sci-ppt:o032"/>
+          <p:cNvSpPr txBox="1"/>
+          <p:nvPr/>
+        </p:nvSpPr>
+        <p:spPr>
+          <a:xfrm>
+            <a:off x="10131552" y="5111496"/>
+            <a:ext cx="914400" cy="208407"/>
+          </a:xfrm>
+          <a:prstGeom prst="rect">
+            <a:avLst/>
+          </a:prstGeom>
+          <a:noFill/>
+          <a:effectLst/>
+        </p:spPr>
+        <p:txBody>
+          <a:bodyPr wrap="none" lIns="18288" rIns="18288" tIns="18288" bIns="18288" anchor="t">
+            <a:spAutoFit/>
+          </a:bodyPr>
+          <a:lstStyle/>
+          <a:p>
+            <a:pPr algn="ctr">
+              <a:spcAft>
+                <a:spcPts val="0"/>
+              </a:spcAft>
+            </a:pPr>
+            <a:r>
+              <a:rPr sz="1050" b="0" i="0">
+                <a:solidFill>
+                  <a:srgbClr val="B4C7D2"/>
+                </a:solidFill>
+                <a:latin typeface="Arial"/>
+              </a:rPr>
+              <a:t>5</a:t>
+            </a:r>
+          </a:p>
+        </p:txBody>
+      </p:sp>
+      <p:cxnSp>
+        <p:nvCxnSpPr>
+          <p:cNvPr id="35" name="A-E01 line 33" descr="sci-ppt:o033"/>
+          <p:cNvCxnSpPr/>
+          <p:nvPr/>
+        </p:nvCxnSpPr>
+        <p:spPr>
+          <a:xfrm>
+            <a:off x="11704320" y="5029200"/>
+            <a:ext cx="0" cy="64008"/>
+          </a:xfrm>
+          <a:prstGeom prst="line">
+            <a:avLst/>
+          </a:prstGeom>
+          <a:ln w="12700">
+            <a:solidFill>
+              <a:srgbClr val="B4C7D2"/>
+            </a:solidFill>
+          </a:ln>
+          <a:effectLst/>
+        </p:spPr>
+      </p:cxnSp>
+      <p:cxnSp>
+        <p:nvCxnSpPr>
+          <p:cNvPr id="36" name="A-E01 line 34" descr="sci-ppt:o034"/>
+          <p:cNvCxnSpPr/>
+          <p:nvPr/>
+        </p:nvCxnSpPr>
+        <p:spPr>
+          <a:xfrm>
+            <a:off x="11704320" y="1371600"/>
+            <a:ext cx="0" cy="3657600"/>
+          </a:xfrm>
+          <a:prstGeom prst="line">
+            <a:avLst/>
+          </a:prstGeom>
+          <a:ln w="7620">
+            <a:solidFill>
+              <a:srgbClr val="2E4756"/>
+            </a:solidFill>
+          </a:ln>
+          <a:effectLst/>
+        </p:spPr>
+      </p:cxnSp>
+      <p:sp>
+        <p:nvSpPr>
+          <p:cNvPr id="37" name="A-E01 text 35" descr="sci-ppt:o035"/>
+          <p:cNvSpPr txBox="1"/>
+          <p:nvPr/>
+        </p:nvSpPr>
+        <p:spPr>
+          <a:xfrm>
+            <a:off x="11247120" y="5111496"/>
+            <a:ext cx="914400" cy="208407"/>
+          </a:xfrm>
+          <a:prstGeom prst="rect">
+            <a:avLst/>
+          </a:prstGeom>
+          <a:noFill/>
+          <a:effectLst/>
+        </p:spPr>
+        <p:txBody>
+          <a:bodyPr wrap="none" lIns="18288" rIns="18288" tIns="18288" bIns="18288" anchor="t">
+            <a:spAutoFit/>
+          </a:bodyPr>
+          <a:lstStyle/>
+          <a:p>
+            <a:pPr algn="ctr">
+              <a:spcAft>
+                <a:spcPts val="0"/>
+              </a:spcAft>
+            </a:pPr>
+            <a:r>
+              <a:rPr sz="1050" b="0" i="0">
+                <a:solidFill>
+                  <a:srgbClr val="B4C7D2"/>
+                </a:solidFill>
+                <a:latin typeface="Arial"/>
+              </a:rPr>
+              <a:t>6</a:t>
+            </a:r>
+          </a:p>
+        </p:txBody>
+      </p:sp>
+      <p:cxnSp>
+        <p:nvCxnSpPr>
+          <p:cNvPr id="38" name="A-E01 line 36" descr="sci-ppt:o036"/>
+          <p:cNvCxnSpPr/>
+          <p:nvPr/>
+        </p:nvCxnSpPr>
+        <p:spPr>
+          <a:xfrm>
+            <a:off x="6062472" y="5029200"/>
+            <a:ext cx="64008" cy="0"/>
+          </a:xfrm>
+          <a:prstGeom prst="line">
+            <a:avLst/>
+          </a:prstGeom>
+          <a:ln w="12700">
+            <a:solidFill>
+              <a:srgbClr val="B4C7D2"/>
+            </a:solidFill>
+          </a:ln>
+          <a:effectLst/>
+        </p:spPr>
+      </p:cxnSp>
+      <p:cxnSp>
+        <p:nvCxnSpPr>
+          <p:cNvPr id="39" name="A-E01 line 37" descr="sci-ppt:o037"/>
+          <p:cNvCxnSpPr/>
+          <p:nvPr/>
+        </p:nvCxnSpPr>
+        <p:spPr>
+          <a:xfrm>
+            <a:off x="6062472" y="4419600"/>
+            <a:ext cx="64008" cy="0"/>
+          </a:xfrm>
+          <a:prstGeom prst="line">
+            <a:avLst/>
+          </a:prstGeom>
+          <a:ln w="12700">
+            <a:solidFill>
+              <a:srgbClr val="B4C7D2"/>
+            </a:solidFill>
+          </a:ln>
+          <a:effectLst/>
+        </p:spPr>
+      </p:cxnSp>
+      <p:cxnSp>
+        <p:nvCxnSpPr>
+          <p:cNvPr id="40" name="A-E01 line 38" descr="sci-ppt:o038"/>
+          <p:cNvCxnSpPr/>
+          <p:nvPr/>
+        </p:nvCxnSpPr>
+        <p:spPr>
+          <a:xfrm>
+            <a:off x="6126480" y="4419600"/>
+            <a:ext cx="5577840" cy="0"/>
+          </a:xfrm>
+          <a:prstGeom prst="line">
+            <a:avLst/>
+          </a:prstGeom>
+          <a:ln w="7620">
+            <a:solidFill>
+              <a:srgbClr val="2E4756"/>
+            </a:solidFill>
+          </a:ln>
+          <a:effectLst/>
+        </p:spPr>
+      </p:cxnSp>
+      <p:sp>
+        <p:nvSpPr>
+          <p:cNvPr id="41" name="A-E01 text 39" descr="sci-ppt:o039"/>
+          <p:cNvSpPr txBox="1"/>
+          <p:nvPr/>
+        </p:nvSpPr>
+        <p:spPr>
+          <a:xfrm>
+            <a:off x="5257800" y="4337304"/>
+            <a:ext cx="777240" cy="208407"/>
+          </a:xfrm>
+          <a:prstGeom prst="rect">
+            <a:avLst/>
+          </a:prstGeom>
+          <a:noFill/>
+          <a:effectLst/>
+        </p:spPr>
+        <p:txBody>
+          <a:bodyPr wrap="none" lIns="18288" rIns="18288" tIns="18288" bIns="18288" anchor="t">
+            <a:spAutoFit/>
+          </a:bodyPr>
+          <a:lstStyle/>
+          <a:p>
+            <a:pPr algn="r">
+              <a:spcAft>
+                <a:spcPts val="0"/>
+              </a:spcAft>
+            </a:pPr>
+            <a:r>
+              <a:rPr sz="1050" b="0" i="0">
+                <a:solidFill>
+                  <a:srgbClr val="B4C7D2"/>
+                </a:solidFill>
+                <a:latin typeface="Arial"/>
+              </a:rPr>
+              <a:t>1</a:t>
+            </a:r>
+          </a:p>
+        </p:txBody>
+      </p:sp>
+      <p:cxnSp>
+        <p:nvCxnSpPr>
+          <p:cNvPr id="42" name="A-E01 line 40" descr="sci-ppt:o040"/>
+          <p:cNvCxnSpPr/>
+          <p:nvPr/>
+        </p:nvCxnSpPr>
+        <p:spPr>
+          <a:xfrm>
+            <a:off x="6062472" y="3810000"/>
+            <a:ext cx="64008" cy="0"/>
+          </a:xfrm>
+          <a:prstGeom prst="line">
+            <a:avLst/>
+          </a:prstGeom>
+          <a:ln w="12700">
+            <a:solidFill>
+              <a:srgbClr val="B4C7D2"/>
+            </a:solidFill>
+          </a:ln>
+          <a:effectLst/>
+        </p:spPr>
+      </p:cxnSp>
+      <p:cxnSp>
+        <p:nvCxnSpPr>
+          <p:cNvPr id="43" name="A-E01 line 41" descr="sci-ppt:o041"/>
+          <p:cNvCxnSpPr/>
+          <p:nvPr/>
+        </p:nvCxnSpPr>
+        <p:spPr>
+          <a:xfrm>
+            <a:off x="6126480" y="3810000"/>
+            <a:ext cx="5577840" cy="0"/>
+          </a:xfrm>
+          <a:prstGeom prst="line">
+            <a:avLst/>
+          </a:prstGeom>
+          <a:ln w="7620">
+            <a:solidFill>
+              <a:srgbClr val="2E4756"/>
+            </a:solidFill>
+          </a:ln>
+          <a:effectLst/>
+        </p:spPr>
+      </p:cxnSp>
+      <p:sp>
+        <p:nvSpPr>
+          <p:cNvPr id="44" name="A-E01 text 42" descr="sci-ppt:o042"/>
+          <p:cNvSpPr txBox="1"/>
+          <p:nvPr/>
+        </p:nvSpPr>
+        <p:spPr>
+          <a:xfrm>
+            <a:off x="5257800" y="3727704"/>
+            <a:ext cx="777240" cy="208407"/>
+          </a:xfrm>
+          <a:prstGeom prst="rect">
+            <a:avLst/>
+          </a:prstGeom>
+          <a:noFill/>
+          <a:effectLst/>
+        </p:spPr>
+        <p:txBody>
+          <a:bodyPr wrap="none" lIns="18288" rIns="18288" tIns="18288" bIns="18288" anchor="t">
+            <a:spAutoFit/>
+          </a:bodyPr>
+          <a:lstStyle/>
+          <a:p>
+            <a:pPr algn="r">
+              <a:spcAft>
+                <a:spcPts val="0"/>
+              </a:spcAft>
+            </a:pPr>
+            <a:r>
+              <a:rPr sz="1050" b="0" i="0">
+                <a:solidFill>
+                  <a:srgbClr val="B4C7D2"/>
+                </a:solidFill>
+                <a:latin typeface="Arial"/>
+              </a:rPr>
+              <a:t>2</a:t>
+            </a:r>
+          </a:p>
+        </p:txBody>
+      </p:sp>
+      <p:cxnSp>
+        <p:nvCxnSpPr>
+          <p:cNvPr id="45" name="A-E01 line 43" descr="sci-ppt:o043"/>
+          <p:cNvCxnSpPr/>
+          <p:nvPr/>
+        </p:nvCxnSpPr>
+        <p:spPr>
+          <a:xfrm>
+            <a:off x="6062472" y="3200400"/>
+            <a:ext cx="64008" cy="0"/>
+          </a:xfrm>
+          <a:prstGeom prst="line">
+            <a:avLst/>
+          </a:prstGeom>
+          <a:ln w="12700">
+            <a:solidFill>
+              <a:srgbClr val="B4C7D2"/>
+            </a:solidFill>
+          </a:ln>
+          <a:effectLst/>
+        </p:spPr>
+      </p:cxnSp>
+      <p:cxnSp>
+        <p:nvCxnSpPr>
+          <p:cNvPr id="46" name="A-E01 line 44" descr="sci-ppt:o044"/>
+          <p:cNvCxnSpPr/>
+          <p:nvPr/>
+        </p:nvCxnSpPr>
+        <p:spPr>
+          <a:xfrm>
+            <a:off x="6126480" y="3200400"/>
+            <a:ext cx="5577840" cy="0"/>
+          </a:xfrm>
+          <a:prstGeom prst="line">
+            <a:avLst/>
+          </a:prstGeom>
+          <a:ln w="7620">
+            <a:solidFill>
+              <a:srgbClr val="2E4756"/>
+            </a:solidFill>
+          </a:ln>
+          <a:effectLst/>
+        </p:spPr>
+      </p:cxnSp>
+      <p:sp>
+        <p:nvSpPr>
+          <p:cNvPr id="47" name="A-E01 text 45" descr="sci-ppt:o045"/>
+          <p:cNvSpPr txBox="1"/>
+          <p:nvPr/>
+        </p:nvSpPr>
+        <p:spPr>
+          <a:xfrm>
+            <a:off x="5257800" y="3118104"/>
+            <a:ext cx="777240" cy="208407"/>
+          </a:xfrm>
+          <a:prstGeom prst="rect">
+            <a:avLst/>
+          </a:prstGeom>
+          <a:noFill/>
+          <a:effectLst/>
+        </p:spPr>
+        <p:txBody>
+          <a:bodyPr wrap="none" lIns="18288" rIns="18288" tIns="18288" bIns="18288" anchor="t">
+            <a:spAutoFit/>
+          </a:bodyPr>
+          <a:lstStyle/>
+          <a:p>
+            <a:pPr algn="r">
+              <a:spcAft>
+                <a:spcPts val="0"/>
+              </a:spcAft>
+            </a:pPr>
+            <a:r>
+              <a:rPr sz="1050" b="0" i="0">
+                <a:solidFill>
+                  <a:srgbClr val="B4C7D2"/>
+                </a:solidFill>
+                <a:latin typeface="Arial"/>
+              </a:rPr>
+              <a:t>3</a:t>
+            </a:r>
+          </a:p>
+        </p:txBody>
+      </p:sp>
+      <p:cxnSp>
+        <p:nvCxnSpPr>
+          <p:cNvPr id="48" name="A-E01 line 46" descr="sci-ppt:o046"/>
+          <p:cNvCxnSpPr/>
+          <p:nvPr/>
+        </p:nvCxnSpPr>
+        <p:spPr>
+          <a:xfrm>
+            <a:off x="6062472" y="2590800"/>
+            <a:ext cx="64008" cy="0"/>
+          </a:xfrm>
+          <a:prstGeom prst="line">
+            <a:avLst/>
+          </a:prstGeom>
+          <a:ln w="12700">
+            <a:solidFill>
+              <a:srgbClr val="B4C7D2"/>
+            </a:solidFill>
+          </a:ln>
+          <a:effectLst/>
+        </p:spPr>
+      </p:cxnSp>
+      <p:cxnSp>
+        <p:nvCxnSpPr>
+          <p:cNvPr id="49" name="A-E01 line 47" descr="sci-ppt:o047"/>
+          <p:cNvCxnSpPr/>
+          <p:nvPr/>
+        </p:nvCxnSpPr>
+        <p:spPr>
+          <a:xfrm>
+            <a:off x="6126480" y="2590800"/>
+            <a:ext cx="5577840" cy="0"/>
+          </a:xfrm>
+          <a:prstGeom prst="line">
+            <a:avLst/>
+          </a:prstGeom>
+          <a:ln w="7620">
+            <a:solidFill>
+              <a:srgbClr val="2E4756"/>
+            </a:solidFill>
+          </a:ln>
+          <a:effectLst/>
+        </p:spPr>
+      </p:cxnSp>
+      <p:sp>
+        <p:nvSpPr>
+          <p:cNvPr id="50" name="A-E01 text 48" descr="sci-ppt:o048"/>
+          <p:cNvSpPr txBox="1"/>
+          <p:nvPr/>
+        </p:nvSpPr>
+        <p:spPr>
+          <a:xfrm>
+            <a:off x="5257800" y="2508504"/>
+            <a:ext cx="777240" cy="208407"/>
+          </a:xfrm>
+          <a:prstGeom prst="rect">
+            <a:avLst/>
+          </a:prstGeom>
+          <a:noFill/>
+          <a:effectLst/>
+        </p:spPr>
+        <p:txBody>
+          <a:bodyPr wrap="none" lIns="18288" rIns="18288" tIns="18288" bIns="18288" anchor="t">
+            <a:spAutoFit/>
+          </a:bodyPr>
+          <a:lstStyle/>
+          <a:p>
+            <a:pPr algn="r">
+              <a:spcAft>
+                <a:spcPts val="0"/>
+              </a:spcAft>
+            </a:pPr>
+            <a:r>
+              <a:rPr sz="1050" b="0" i="0">
+                <a:solidFill>
+                  <a:srgbClr val="B4C7D2"/>
+                </a:solidFill>
+                <a:latin typeface="Arial"/>
+              </a:rPr>
+              <a:t>4</a:t>
+            </a:r>
+          </a:p>
+        </p:txBody>
+      </p:sp>
+      <p:cxnSp>
+        <p:nvCxnSpPr>
+          <p:cNvPr id="51" name="A-E01 line 49" descr="sci-ppt:o049"/>
+          <p:cNvCxnSpPr/>
+          <p:nvPr/>
+        </p:nvCxnSpPr>
+        <p:spPr>
+          <a:xfrm>
+            <a:off x="6062472" y="1981199"/>
+            <a:ext cx="64008" cy="0"/>
+          </a:xfrm>
+          <a:prstGeom prst="line">
+            <a:avLst/>
+          </a:prstGeom>
+          <a:ln w="12700">
+            <a:solidFill>
+              <a:srgbClr val="B4C7D2"/>
+            </a:solidFill>
+          </a:ln>
+          <a:effectLst/>
+        </p:spPr>
+      </p:cxnSp>
+      <p:cxnSp>
+        <p:nvCxnSpPr>
+          <p:cNvPr id="52" name="A-E01 line 50" descr="sci-ppt:o050"/>
+          <p:cNvCxnSpPr/>
+          <p:nvPr/>
+        </p:nvCxnSpPr>
+        <p:spPr>
+          <a:xfrm>
+            <a:off x="6126480" y="1981199"/>
+            <a:ext cx="5577840" cy="0"/>
+          </a:xfrm>
+          <a:prstGeom prst="line">
+            <a:avLst/>
+          </a:prstGeom>
+          <a:ln w="7620">
+            <a:solidFill>
+              <a:srgbClr val="2E4756"/>
+            </a:solidFill>
+          </a:ln>
+          <a:effectLst/>
+        </p:spPr>
+      </p:cxnSp>
+      <p:sp>
+        <p:nvSpPr>
+          <p:cNvPr id="53" name="A-E01 text 51" descr="sci-ppt:o051"/>
+          <p:cNvSpPr txBox="1"/>
+          <p:nvPr/>
+        </p:nvSpPr>
+        <p:spPr>
+          <a:xfrm>
+            <a:off x="5257800" y="1898904"/>
+            <a:ext cx="777240" cy="208407"/>
+          </a:xfrm>
+          <a:prstGeom prst="rect">
+            <a:avLst/>
+          </a:prstGeom>
+          <a:noFill/>
+          <a:effectLst/>
+        </p:spPr>
+        <p:txBody>
+          <a:bodyPr wrap="none" lIns="18288" rIns="18288" tIns="18288" bIns="18288" anchor="t">
+            <a:spAutoFit/>
+          </a:bodyPr>
+          <a:lstStyle/>
+          <a:p>
+            <a:pPr algn="r">
+              <a:spcAft>
+                <a:spcPts val="0"/>
+              </a:spcAft>
+            </a:pPr>
+            <a:r>
+              <a:rPr sz="1050" b="0" i="0">
+                <a:solidFill>
+                  <a:srgbClr val="B4C7D2"/>
+                </a:solidFill>
+                <a:latin typeface="Arial"/>
+              </a:rPr>
+              <a:t>5</a:t>
+            </a:r>
+          </a:p>
+        </p:txBody>
+      </p:sp>
+      <p:cxnSp>
+        <p:nvCxnSpPr>
+          <p:cNvPr id="54" name="A-E01 line 52" descr="sci-ppt:o052"/>
+          <p:cNvCxnSpPr/>
+          <p:nvPr/>
+        </p:nvCxnSpPr>
+        <p:spPr>
+          <a:xfrm>
+            <a:off x="6062472" y="1371600"/>
+            <a:ext cx="64008" cy="0"/>
+          </a:xfrm>
+          <a:prstGeom prst="line">
+            <a:avLst/>
+          </a:prstGeom>
+          <a:ln w="12700">
+            <a:solidFill>
+              <a:srgbClr val="B4C7D2"/>
+            </a:solidFill>
+          </a:ln>
+          <a:effectLst/>
+        </p:spPr>
+      </p:cxnSp>
+      <p:cxnSp>
+        <p:nvCxnSpPr>
+          <p:cNvPr id="55" name="A-E01 line 53" descr="sci-ppt:o053"/>
+          <p:cNvCxnSpPr/>
+          <p:nvPr/>
+        </p:nvCxnSpPr>
+        <p:spPr>
+          <a:xfrm>
+            <a:off x="6126480" y="1371600"/>
+            <a:ext cx="5577840" cy="0"/>
+          </a:xfrm>
+          <a:prstGeom prst="line">
+            <a:avLst/>
+          </a:prstGeom>
+          <a:ln w="7620">
+            <a:solidFill>
+              <a:srgbClr val="2E4756"/>
+            </a:solidFill>
+          </a:ln>
+          <a:effectLst/>
+        </p:spPr>
+      </p:cxnSp>
+      <p:sp>
+        <p:nvSpPr>
+          <p:cNvPr id="56" name="A-E01 text 54" descr="sci-ppt:o054"/>
+          <p:cNvSpPr txBox="1"/>
+          <p:nvPr/>
+        </p:nvSpPr>
+        <p:spPr>
+          <a:xfrm>
+            <a:off x="5257800" y="1289304"/>
+            <a:ext cx="777240" cy="208407"/>
+          </a:xfrm>
+          <a:prstGeom prst="rect">
+            <a:avLst/>
+          </a:prstGeom>
+          <a:noFill/>
+          <a:effectLst/>
+        </p:spPr>
+        <p:txBody>
+          <a:bodyPr wrap="none" lIns="18288" rIns="18288" tIns="18288" bIns="18288" anchor="t">
+            <a:spAutoFit/>
+          </a:bodyPr>
+          <a:lstStyle/>
+          <a:p>
+            <a:pPr algn="r">
+              <a:spcAft>
+                <a:spcPts val="0"/>
+              </a:spcAft>
+            </a:pPr>
+            <a:r>
+              <a:rPr sz="1050" b="0" i="0">
+                <a:solidFill>
+                  <a:srgbClr val="B4C7D2"/>
+                </a:solidFill>
+                <a:latin typeface="Arial"/>
+              </a:rPr>
+              <a:t>6</a:t>
+            </a:r>
+          </a:p>
+        </p:txBody>
+      </p:sp>
+      <p:sp>
+        <p:nvSpPr>
+          <p:cNvPr id="57" name="A-E01 text 55" descr="sci-ppt:o055"/>
+          <p:cNvSpPr txBox="1"/>
+          <p:nvPr/>
+        </p:nvSpPr>
+        <p:spPr>
+          <a:xfrm>
+            <a:off x="6126480" y="5312664"/>
+            <a:ext cx="5577840" cy="231648"/>
+          </a:xfrm>
+          <a:prstGeom prst="rect">
+            <a:avLst/>
+          </a:prstGeom>
+          <a:noFill/>
+          <a:effectLst/>
+        </p:spPr>
+        <p:txBody>
+          <a:bodyPr wrap="none" lIns="18288" rIns="18288" tIns="18288" bIns="18288" anchor="t">
+            <a:spAutoFit/>
+          </a:bodyPr>
+          <a:lstStyle/>
+          <a:p>
+            <a:pPr algn="ctr">
+              <a:spcAft>
+                <a:spcPts val="0"/>
+              </a:spcAft>
+            </a:pPr>
+            <a:r>
+              <a:rPr sz="1200" b="0" i="0">
                 <a:solidFill>
                   <a:srgbClr val="E7F0F3"/>
                 </a:solidFill>
                 <a:latin typeface="Arial"/>
               </a:rPr>
-              <a:t>r₀</a:t>
-            </a:r>
-          </a:p>
-        </p:txBody>
-      </p:sp>
-      <p:sp>
-        <p:nvSpPr>
-          <p:cNvPr id="9" name="ellipse 7" descr="sci-ppt:obj-007"/>
-          <p:cNvSpPr/>
-          <p:nvPr/>
-        </p:nvSpPr>
-        <p:spPr>
-          <a:xfrm>
-            <a:off x="4682139" y="750219"/>
-            <a:ext cx="1791401" cy="1791401"/>
-          </a:xfrm>
-          <a:prstGeom prst="ellipse">
-            <a:avLst/>
-          </a:prstGeom>
-          <a:noFill/>
-          <a:ln w="17780">
-            <a:solidFill>
-              <a:srgbClr val="B4C7D2"/>
-            </a:solidFill>
-          </a:ln>
-          <a:effectLst/>
-        </p:spPr>
-        <p:txBody>
-          <a:bodyPr rtlCol="0" anchor="ctr"/>
-          <a:lstStyle/>
-          <a:p>
-            <a:pPr algn="ctr"/>
-          </a:p>
-        </p:txBody>
-      </p:sp>
-      <p:sp>
-        <p:nvSpPr>
-          <p:cNvPr id="10" name="ellipse 8" descr="sci-ppt:obj-008"/>
-          <p:cNvSpPr/>
-          <p:nvPr/>
-        </p:nvSpPr>
-        <p:spPr>
-          <a:xfrm>
-            <a:off x="4864608" y="932688"/>
-            <a:ext cx="1426464" cy="1426464"/>
-          </a:xfrm>
-          <a:prstGeom prst="ellipse">
-            <a:avLst/>
-          </a:prstGeom>
-          <a:solidFill>
-            <a:srgbClr val="213E4B"/>
-          </a:solidFill>
-          <a:ln w="17780">
-            <a:solidFill>
-              <a:srgbClr val="B4C7D2"/>
-            </a:solidFill>
-          </a:ln>
-          <a:effectLst/>
-        </p:spPr>
-        <p:txBody>
-          <a:bodyPr rtlCol="0" anchor="ctr"/>
-          <a:lstStyle/>
-          <a:p>
-            <a:pPr algn="ctr"/>
-          </a:p>
-        </p:txBody>
-      </p:sp>
-      <p:cxnSp>
-        <p:nvCxnSpPr>
-          <p:cNvPr id="11" name="arrow 9" descr="sci-ppt:obj-009"/>
-          <p:cNvCxnSpPr/>
-          <p:nvPr/>
-        </p:nvCxnSpPr>
-        <p:spPr>
-          <a:xfrm>
-            <a:off x="5577840" y="1645920"/>
-            <a:ext cx="713232" cy="0"/>
-          </a:xfrm>
-          <a:prstGeom prst="line">
-            <a:avLst/>
-          </a:prstGeom>
-          <a:ln w="21590">
-            <a:solidFill>
-              <a:srgbClr val="8EDBD4"/>
-            </a:solidFill>
-            <a:headEnd type="none" w="med" len="med"/>
-            <a:tailEnd type="triangle" w="med" len="med"/>
-          </a:ln>
-          <a:effectLst/>
-        </p:spPr>
-      </p:cxnSp>
-      <p:sp>
-        <p:nvSpPr>
-          <p:cNvPr id="12" name="text 10" descr="sci-ppt:obj-010"/>
+              <a:t>reference radius r₀ / R_ref</a:t>
+            </a:r>
+          </a:p>
+        </p:txBody>
+      </p:sp>
+      <p:sp>
+        <p:nvSpPr>
+          <p:cNvPr id="58" name="A-E01 text 56" descr="sci-ppt:o056"/>
           <p:cNvSpPr txBox="1"/>
           <p:nvPr/>
         </p:nvSpPr>
         <p:spPr>
           <a:xfrm>
-            <a:off x="5952744" y="1271016"/>
-            <a:ext cx="640080" cy="310896"/>
+            <a:off x="5577840" y="1024128"/>
+            <a:ext cx="5577840" cy="231648"/>
           </a:xfrm>
           <a:prstGeom prst="rect">
             <a:avLst/>
@@ -3430,7 +4788,7 @@
           <a:effectLst/>
         </p:spPr>
         <p:txBody>
-          <a:bodyPr wrap="none" lIns="0" rIns="0" tIns="0" bIns="0" anchor="ctr">
+          <a:bodyPr wrap="none" lIns="18288" rIns="18288" tIns="18288" bIns="18288" anchor="t">
             <a:spAutoFit/>
           </a:bodyPr>
           <a:lstStyle/>
@@ -3441,51 +4799,1939 @@
               </a:spcAft>
             </a:pPr>
             <a:r>
-              <a:rPr sz="1296" b="0" i="0">
+              <a:rPr sz="1200" b="0" i="0">
                 <a:solidFill>
                   <a:srgbClr val="E7F0F3"/>
                 </a:solidFill>
                 <a:latin typeface="Arial"/>
               </a:rPr>
-              <a:t>R</a:t>
-            </a:r>
-          </a:p>
-        </p:txBody>
-      </p:sp>
-      <p:cxnSp>
-        <p:nvCxnSpPr>
-          <p:cNvPr id="13" name="arrow 11" descr="sci-ppt:obj-011"/>
-          <p:cNvCxnSpPr/>
+              <a:t>stretch</a:t>
+            </a:r>
+          </a:p>
+        </p:txBody>
+      </p:sp>
+      <p:sp>
+        <p:nvSpPr>
+          <p:cNvPr id="59" name="A-E01 polygon 57" descr="sci-ppt:o057"/>
+          <p:cNvSpPr/>
           <p:nvPr/>
-        </p:nvCxnSpPr>
-        <p:spPr>
-          <a:xfrm>
-            <a:off x="5577840" y="1645920"/>
-            <a:ext cx="633355" cy="633355"/>
-          </a:xfrm>
-          <a:prstGeom prst="line">
+        </p:nvSpPr>
+        <p:spPr>
+          <a:xfrm>
+            <a:off x="6154509" y="1460821"/>
+            <a:ext cx="5549811" cy="2800924"/>
+          </a:xfrm>
+          <a:custGeom>
             <a:avLst/>
-          </a:prstGeom>
-          <a:ln w="21590">
+            <a:gdLst/>
+            <a:ahLst/>
+            <a:cxnLst/>
+            <a:rect l="l" t="t" r="r" b="b"/>
+            <a:pathLst>
+              <a:path w="5549811" h="2800924">
+                <a:moveTo>
+                  <a:pt x="0" y="0"/>
+                </a:moveTo>
+                <a:lnTo>
+                  <a:pt x="28029" y="84932"/>
+                </a:lnTo>
+                <a:lnTo>
+                  <a:pt x="56059" y="165874"/>
+                </a:lnTo>
+                <a:lnTo>
+                  <a:pt x="84088" y="243100"/>
+                </a:lnTo>
+                <a:lnTo>
+                  <a:pt x="112117" y="316857"/>
+                </a:lnTo>
+                <a:lnTo>
+                  <a:pt x="140147" y="387373"/>
+                </a:lnTo>
+                <a:lnTo>
+                  <a:pt x="168176" y="454854"/>
+                </a:lnTo>
+                <a:lnTo>
+                  <a:pt x="196205" y="519491"/>
+                </a:lnTo>
+                <a:lnTo>
+                  <a:pt x="224235" y="581459"/>
+                </a:lnTo>
+                <a:lnTo>
+                  <a:pt x="252264" y="640917"/>
+                </a:lnTo>
+                <a:lnTo>
+                  <a:pt x="280293" y="698013"/>
+                </a:lnTo>
+                <a:lnTo>
+                  <a:pt x="308323" y="752884"/>
+                </a:lnTo>
+                <a:lnTo>
+                  <a:pt x="336352" y="805656"/>
+                </a:lnTo>
+                <a:lnTo>
+                  <a:pt x="364381" y="856446"/>
+                </a:lnTo>
+                <a:lnTo>
+                  <a:pt x="392411" y="905361"/>
+                </a:lnTo>
+                <a:lnTo>
+                  <a:pt x="420440" y="952503"/>
+                </a:lnTo>
+                <a:lnTo>
+                  <a:pt x="448469" y="997964"/>
+                </a:lnTo>
+                <a:lnTo>
+                  <a:pt x="476499" y="1041831"/>
+                </a:lnTo>
+                <a:lnTo>
+                  <a:pt x="504528" y="1084186"/>
+                </a:lnTo>
+                <a:lnTo>
+                  <a:pt x="532557" y="1125103"/>
+                </a:lnTo>
+                <a:lnTo>
+                  <a:pt x="560587" y="1164654"/>
+                </a:lnTo>
+                <a:lnTo>
+                  <a:pt x="588616" y="1202905"/>
+                </a:lnTo>
+                <a:lnTo>
+                  <a:pt x="616645" y="1239916"/>
+                </a:lnTo>
+                <a:lnTo>
+                  <a:pt x="644675" y="1275747"/>
+                </a:lnTo>
+                <a:lnTo>
+                  <a:pt x="672704" y="1310452"/>
+                </a:lnTo>
+                <a:lnTo>
+                  <a:pt x="700734" y="1344082"/>
+                </a:lnTo>
+                <a:lnTo>
+                  <a:pt x="728763" y="1376684"/>
+                </a:lnTo>
+                <a:lnTo>
+                  <a:pt x="756792" y="1408304"/>
+                </a:lnTo>
+                <a:lnTo>
+                  <a:pt x="784822" y="1438984"/>
+                </a:lnTo>
+                <a:lnTo>
+                  <a:pt x="812851" y="1468766"/>
+                </a:lnTo>
+                <a:lnTo>
+                  <a:pt x="840880" y="1497685"/>
+                </a:lnTo>
+                <a:lnTo>
+                  <a:pt x="868910" y="1525779"/>
+                </a:lnTo>
+                <a:lnTo>
+                  <a:pt x="896939" y="1553081"/>
+                </a:lnTo>
+                <a:lnTo>
+                  <a:pt x="924968" y="1579622"/>
+                </a:lnTo>
+                <a:lnTo>
+                  <a:pt x="952998" y="1605434"/>
+                </a:lnTo>
+                <a:lnTo>
+                  <a:pt x="981027" y="1630545"/>
+                </a:lnTo>
+                <a:lnTo>
+                  <a:pt x="1009056" y="1654981"/>
+                </a:lnTo>
+                <a:lnTo>
+                  <a:pt x="1037086" y="1678770"/>
+                </a:lnTo>
+                <a:lnTo>
+                  <a:pt x="1065115" y="1701934"/>
+                </a:lnTo>
+                <a:lnTo>
+                  <a:pt x="1093144" y="1724498"/>
+                </a:lnTo>
+                <a:lnTo>
+                  <a:pt x="1121174" y="1746484"/>
+                </a:lnTo>
+                <a:lnTo>
+                  <a:pt x="1149203" y="1767912"/>
+                </a:lnTo>
+                <a:lnTo>
+                  <a:pt x="1177232" y="1788803"/>
+                </a:lnTo>
+                <a:lnTo>
+                  <a:pt x="1205262" y="1809176"/>
+                </a:lnTo>
+                <a:lnTo>
+                  <a:pt x="1233291" y="1829048"/>
+                </a:lnTo>
+                <a:lnTo>
+                  <a:pt x="1261320" y="1848437"/>
+                </a:lnTo>
+                <a:lnTo>
+                  <a:pt x="1289350" y="1867360"/>
+                </a:lnTo>
+                <a:lnTo>
+                  <a:pt x="1317379" y="1885832"/>
+                </a:lnTo>
+                <a:lnTo>
+                  <a:pt x="1345408" y="1903869"/>
+                </a:lnTo>
+                <a:lnTo>
+                  <a:pt x="1373438" y="1921484"/>
+                </a:lnTo>
+                <a:lnTo>
+                  <a:pt x="1401467" y="1938692"/>
+                </a:lnTo>
+                <a:lnTo>
+                  <a:pt x="1429497" y="1955506"/>
+                </a:lnTo>
+                <a:lnTo>
+                  <a:pt x="1457526" y="1971938"/>
+                </a:lnTo>
+                <a:lnTo>
+                  <a:pt x="1485555" y="1988000"/>
+                </a:lnTo>
+                <a:lnTo>
+                  <a:pt x="1513585" y="2003705"/>
+                </a:lnTo>
+                <a:lnTo>
+                  <a:pt x="1541614" y="2019062"/>
+                </a:lnTo>
+                <a:lnTo>
+                  <a:pt x="1569643" y="2034083"/>
+                </a:lnTo>
+                <a:lnTo>
+                  <a:pt x="1597673" y="2048777"/>
+                </a:lnTo>
+                <a:lnTo>
+                  <a:pt x="1625702" y="2063155"/>
+                </a:lnTo>
+                <a:lnTo>
+                  <a:pt x="1653731" y="2077227"/>
+                </a:lnTo>
+                <a:lnTo>
+                  <a:pt x="1681761" y="2091000"/>
+                </a:lnTo>
+                <a:lnTo>
+                  <a:pt x="1709790" y="2104483"/>
+                </a:lnTo>
+                <a:lnTo>
+                  <a:pt x="1737819" y="2117686"/>
+                </a:lnTo>
+                <a:lnTo>
+                  <a:pt x="1765849" y="2130615"/>
+                </a:lnTo>
+                <a:lnTo>
+                  <a:pt x="1793878" y="2143279"/>
+                </a:lnTo>
+                <a:lnTo>
+                  <a:pt x="1821907" y="2155685"/>
+                </a:lnTo>
+                <a:lnTo>
+                  <a:pt x="1849937" y="2167841"/>
+                </a:lnTo>
+                <a:lnTo>
+                  <a:pt x="1877966" y="2179752"/>
+                </a:lnTo>
+                <a:lnTo>
+                  <a:pt x="1905995" y="2191426"/>
+                </a:lnTo>
+                <a:lnTo>
+                  <a:pt x="1934025" y="2202870"/>
+                </a:lnTo>
+                <a:lnTo>
+                  <a:pt x="1962054" y="2214088"/>
+                </a:lnTo>
+                <a:lnTo>
+                  <a:pt x="1990083" y="2225088"/>
+                </a:lnTo>
+                <a:lnTo>
+                  <a:pt x="2018113" y="2235874"/>
+                </a:lnTo>
+                <a:lnTo>
+                  <a:pt x="2046142" y="2246453"/>
+                </a:lnTo>
+                <a:lnTo>
+                  <a:pt x="2074172" y="2256830"/>
+                </a:lnTo>
+                <a:lnTo>
+                  <a:pt x="2102201" y="2267010"/>
+                </a:lnTo>
+                <a:lnTo>
+                  <a:pt x="2130230" y="2276998"/>
+                </a:lnTo>
+                <a:lnTo>
+                  <a:pt x="2158260" y="2286798"/>
+                </a:lnTo>
+                <a:lnTo>
+                  <a:pt x="2186289" y="2296416"/>
+                </a:lnTo>
+                <a:lnTo>
+                  <a:pt x="2214318" y="2305856"/>
+                </a:lnTo>
+                <a:lnTo>
+                  <a:pt x="2242348" y="2315122"/>
+                </a:lnTo>
+                <a:lnTo>
+                  <a:pt x="2270377" y="2324219"/>
+                </a:lnTo>
+                <a:lnTo>
+                  <a:pt x="2298406" y="2333150"/>
+                </a:lnTo>
+                <a:lnTo>
+                  <a:pt x="2326436" y="2341920"/>
+                </a:lnTo>
+                <a:lnTo>
+                  <a:pt x="2354465" y="2350532"/>
+                </a:lnTo>
+                <a:lnTo>
+                  <a:pt x="2382494" y="2358990"/>
+                </a:lnTo>
+                <a:lnTo>
+                  <a:pt x="2410524" y="2367298"/>
+                </a:lnTo>
+                <a:lnTo>
+                  <a:pt x="2438553" y="2375459"/>
+                </a:lnTo>
+                <a:lnTo>
+                  <a:pt x="2466582" y="2383476"/>
+                </a:lnTo>
+                <a:lnTo>
+                  <a:pt x="2494612" y="2391353"/>
+                </a:lnTo>
+                <a:lnTo>
+                  <a:pt x="2522641" y="2399094"/>
+                </a:lnTo>
+                <a:lnTo>
+                  <a:pt x="2550670" y="2406700"/>
+                </a:lnTo>
+                <a:lnTo>
+                  <a:pt x="2578700" y="2414175"/>
+                </a:lnTo>
+                <a:lnTo>
+                  <a:pt x="2606729" y="2421523"/>
+                </a:lnTo>
+                <a:lnTo>
+                  <a:pt x="2634758" y="2428745"/>
+                </a:lnTo>
+                <a:lnTo>
+                  <a:pt x="2662788" y="2435844"/>
+                </a:lnTo>
+                <a:lnTo>
+                  <a:pt x="2690817" y="2442824"/>
+                </a:lnTo>
+                <a:lnTo>
+                  <a:pt x="2718846" y="2449686"/>
+                </a:lnTo>
+                <a:lnTo>
+                  <a:pt x="2746876" y="2456434"/>
+                </a:lnTo>
+                <a:lnTo>
+                  <a:pt x="2774905" y="2463069"/>
+                </a:lnTo>
+                <a:lnTo>
+                  <a:pt x="2802935" y="2469595"/>
+                </a:lnTo>
+                <a:lnTo>
+                  <a:pt x="2830964" y="2476012"/>
+                </a:lnTo>
+                <a:lnTo>
+                  <a:pt x="2858993" y="2482325"/>
+                </a:lnTo>
+                <a:lnTo>
+                  <a:pt x="2887023" y="2488534"/>
+                </a:lnTo>
+                <a:lnTo>
+                  <a:pt x="2915052" y="2494642"/>
+                </a:lnTo>
+                <a:lnTo>
+                  <a:pt x="2943081" y="2500651"/>
+                </a:lnTo>
+                <a:lnTo>
+                  <a:pt x="2971111" y="2506564"/>
+                </a:lnTo>
+                <a:lnTo>
+                  <a:pt x="2999140" y="2512381"/>
+                </a:lnTo>
+                <a:lnTo>
+                  <a:pt x="3027169" y="2518105"/>
+                </a:lnTo>
+                <a:lnTo>
+                  <a:pt x="3055199" y="2523738"/>
+                </a:lnTo>
+                <a:lnTo>
+                  <a:pt x="3083228" y="2529281"/>
+                </a:lnTo>
+                <a:lnTo>
+                  <a:pt x="3111257" y="2534737"/>
+                </a:lnTo>
+                <a:lnTo>
+                  <a:pt x="3139287" y="2540107"/>
+                </a:lnTo>
+                <a:lnTo>
+                  <a:pt x="3167316" y="2545392"/>
+                </a:lnTo>
+                <a:lnTo>
+                  <a:pt x="3195345" y="2550595"/>
+                </a:lnTo>
+                <a:lnTo>
+                  <a:pt x="3223375" y="2555717"/>
+                </a:lnTo>
+                <a:lnTo>
+                  <a:pt x="3251404" y="2560759"/>
+                </a:lnTo>
+                <a:lnTo>
+                  <a:pt x="3279433" y="2565724"/>
+                </a:lnTo>
+                <a:lnTo>
+                  <a:pt x="3307463" y="2570612"/>
+                </a:lnTo>
+                <a:lnTo>
+                  <a:pt x="3335492" y="2575425"/>
+                </a:lnTo>
+                <a:lnTo>
+                  <a:pt x="3363521" y="2580164"/>
+                </a:lnTo>
+                <a:lnTo>
+                  <a:pt x="3391551" y="2584831"/>
+                </a:lnTo>
+                <a:lnTo>
+                  <a:pt x="3419580" y="2589427"/>
+                </a:lnTo>
+                <a:lnTo>
+                  <a:pt x="3447609" y="2593954"/>
+                </a:lnTo>
+                <a:lnTo>
+                  <a:pt x="3475639" y="2598412"/>
+                </a:lnTo>
+                <a:lnTo>
+                  <a:pt x="3503668" y="2602804"/>
+                </a:lnTo>
+                <a:lnTo>
+                  <a:pt x="3531698" y="2607129"/>
+                </a:lnTo>
+                <a:lnTo>
+                  <a:pt x="3559727" y="2611390"/>
+                </a:lnTo>
+                <a:lnTo>
+                  <a:pt x="3587756" y="2615588"/>
+                </a:lnTo>
+                <a:lnTo>
+                  <a:pt x="3615786" y="2619723"/>
+                </a:lnTo>
+                <a:lnTo>
+                  <a:pt x="3643815" y="2623797"/>
+                </a:lnTo>
+                <a:lnTo>
+                  <a:pt x="3671844" y="2627811"/>
+                </a:lnTo>
+                <a:lnTo>
+                  <a:pt x="3699874" y="2631766"/>
+                </a:lnTo>
+                <a:lnTo>
+                  <a:pt x="3727903" y="2635663"/>
+                </a:lnTo>
+                <a:lnTo>
+                  <a:pt x="3755932" y="2639503"/>
+                </a:lnTo>
+                <a:lnTo>
+                  <a:pt x="3783962" y="2643287"/>
+                </a:lnTo>
+                <a:lnTo>
+                  <a:pt x="3811991" y="2647016"/>
+                </a:lnTo>
+                <a:lnTo>
+                  <a:pt x="3840020" y="2650691"/>
+                </a:lnTo>
+                <a:lnTo>
+                  <a:pt x="3868050" y="2654313"/>
+                </a:lnTo>
+                <a:lnTo>
+                  <a:pt x="3896079" y="2657883"/>
+                </a:lnTo>
+                <a:lnTo>
+                  <a:pt x="3924108" y="2661402"/>
+                </a:lnTo>
+                <a:lnTo>
+                  <a:pt x="3952138" y="2664870"/>
+                </a:lnTo>
+                <a:lnTo>
+                  <a:pt x="3980167" y="2668289"/>
+                </a:lnTo>
+                <a:lnTo>
+                  <a:pt x="4008196" y="2671659"/>
+                </a:lnTo>
+                <a:lnTo>
+                  <a:pt x="4036226" y="2674981"/>
+                </a:lnTo>
+                <a:lnTo>
+                  <a:pt x="4064255" y="2678256"/>
+                </a:lnTo>
+                <a:lnTo>
+                  <a:pt x="4092284" y="2681485"/>
+                </a:lnTo>
+                <a:lnTo>
+                  <a:pt x="4120314" y="2684669"/>
+                </a:lnTo>
+                <a:lnTo>
+                  <a:pt x="4148343" y="2687808"/>
+                </a:lnTo>
+                <a:lnTo>
+                  <a:pt x="4176373" y="2690902"/>
+                </a:lnTo>
+                <a:lnTo>
+                  <a:pt x="4204402" y="2693954"/>
+                </a:lnTo>
+                <a:lnTo>
+                  <a:pt x="4232431" y="2696963"/>
+                </a:lnTo>
+                <a:lnTo>
+                  <a:pt x="4260461" y="2699930"/>
+                </a:lnTo>
+                <a:lnTo>
+                  <a:pt x="4288490" y="2702856"/>
+                </a:lnTo>
+                <a:lnTo>
+                  <a:pt x="4316519" y="2705742"/>
+                </a:lnTo>
+                <a:lnTo>
+                  <a:pt x="4344549" y="2708587"/>
+                </a:lnTo>
+                <a:lnTo>
+                  <a:pt x="4372578" y="2711394"/>
+                </a:lnTo>
+                <a:lnTo>
+                  <a:pt x="4400607" y="2714162"/>
+                </a:lnTo>
+                <a:lnTo>
+                  <a:pt x="4428637" y="2716892"/>
+                </a:lnTo>
+                <a:lnTo>
+                  <a:pt x="4456666" y="2719585"/>
+                </a:lnTo>
+                <a:lnTo>
+                  <a:pt x="4484695" y="2722242"/>
+                </a:lnTo>
+                <a:lnTo>
+                  <a:pt x="4512725" y="2724862"/>
+                </a:lnTo>
+                <a:lnTo>
+                  <a:pt x="4540754" y="2727446"/>
+                </a:lnTo>
+                <a:lnTo>
+                  <a:pt x="4568783" y="2729996"/>
+                </a:lnTo>
+                <a:lnTo>
+                  <a:pt x="4596813" y="2732511"/>
+                </a:lnTo>
+                <a:lnTo>
+                  <a:pt x="4624842" y="2734992"/>
+                </a:lnTo>
+                <a:lnTo>
+                  <a:pt x="4652871" y="2737440"/>
+                </a:lnTo>
+                <a:lnTo>
+                  <a:pt x="4680901" y="2739856"/>
+                </a:lnTo>
+                <a:lnTo>
+                  <a:pt x="4708930" y="2742239"/>
+                </a:lnTo>
+                <a:lnTo>
+                  <a:pt x="4736959" y="2744590"/>
+                </a:lnTo>
+                <a:lnTo>
+                  <a:pt x="4764989" y="2746910"/>
+                </a:lnTo>
+                <a:lnTo>
+                  <a:pt x="4793018" y="2749199"/>
+                </a:lnTo>
+                <a:lnTo>
+                  <a:pt x="4821047" y="2751458"/>
+                </a:lnTo>
+                <a:lnTo>
+                  <a:pt x="4849077" y="2753686"/>
+                </a:lnTo>
+                <a:lnTo>
+                  <a:pt x="4877106" y="2755886"/>
+                </a:lnTo>
+                <a:lnTo>
+                  <a:pt x="4905136" y="2758057"/>
+                </a:lnTo>
+                <a:lnTo>
+                  <a:pt x="4933165" y="2760199"/>
+                </a:lnTo>
+                <a:lnTo>
+                  <a:pt x="4961194" y="2762313"/>
+                </a:lnTo>
+                <a:lnTo>
+                  <a:pt x="4989224" y="2764399"/>
+                </a:lnTo>
+                <a:lnTo>
+                  <a:pt x="5017253" y="2766458"/>
+                </a:lnTo>
+                <a:lnTo>
+                  <a:pt x="5045282" y="2768491"/>
+                </a:lnTo>
+                <a:lnTo>
+                  <a:pt x="5073312" y="2770497"/>
+                </a:lnTo>
+                <a:lnTo>
+                  <a:pt x="5101341" y="2772477"/>
+                </a:lnTo>
+                <a:lnTo>
+                  <a:pt x="5129370" y="2774431"/>
+                </a:lnTo>
+                <a:lnTo>
+                  <a:pt x="5157400" y="2776360"/>
+                </a:lnTo>
+                <a:lnTo>
+                  <a:pt x="5185429" y="2778265"/>
+                </a:lnTo>
+                <a:lnTo>
+                  <a:pt x="5213458" y="2780145"/>
+                </a:lnTo>
+                <a:lnTo>
+                  <a:pt x="5241488" y="2782001"/>
+                </a:lnTo>
+                <a:lnTo>
+                  <a:pt x="5269517" y="2783833"/>
+                </a:lnTo>
+                <a:lnTo>
+                  <a:pt x="5297546" y="2785642"/>
+                </a:lnTo>
+                <a:lnTo>
+                  <a:pt x="5325576" y="2787427"/>
+                </a:lnTo>
+                <a:lnTo>
+                  <a:pt x="5353605" y="2789190"/>
+                </a:lnTo>
+                <a:lnTo>
+                  <a:pt x="5381634" y="2790931"/>
+                </a:lnTo>
+                <a:lnTo>
+                  <a:pt x="5409664" y="2792650"/>
+                </a:lnTo>
+                <a:lnTo>
+                  <a:pt x="5437693" y="2794347"/>
+                </a:lnTo>
+                <a:lnTo>
+                  <a:pt x="5465722" y="2796022"/>
+                </a:lnTo>
+                <a:lnTo>
+                  <a:pt x="5493752" y="2797677"/>
+                </a:lnTo>
+                <a:lnTo>
+                  <a:pt x="5521781" y="2799310"/>
+                </a:lnTo>
+                <a:lnTo>
+                  <a:pt x="5549811" y="2800924"/>
+                </a:lnTo>
+              </a:path>
+            </a:pathLst>
+          </a:custGeom>
+          <a:noFill/>
+          <a:ln w="38100">
             <a:solidFill>
-              <a:srgbClr val="8EDBD4"/>
+              <a:srgbClr val="F2B880"/>
             </a:solidFill>
-            <a:headEnd type="none" w="med" len="med"/>
-            <a:tailEnd type="triangle" w="med" len="med"/>
           </a:ln>
           <a:effectLst/>
         </p:spPr>
-      </p:cxnSp>
-      <p:sp>
-        <p:nvSpPr>
-          <p:cNvPr id="14" name="text 12" descr="sci-ppt:obj-012"/>
+        <p:txBody>
+          <a:bodyPr rtlCol="0" anchor="ctr"/>
+          <a:lstStyle/>
+          <a:p>
+            <a:pPr algn="ctr"/>
+          </a:p>
+        </p:txBody>
+      </p:sp>
+      <p:sp>
+        <p:nvSpPr>
+          <p:cNvPr id="60" name="A-E01 polygon 58" descr="sci-ppt:o058"/>
+          <p:cNvSpPr/>
+          <p:nvPr/>
+        </p:nvSpPr>
+        <p:spPr>
+          <a:xfrm>
+            <a:off x="6126480" y="4644582"/>
+            <a:ext cx="5577840" cy="367684"/>
+          </a:xfrm>
+          <a:custGeom>
+            <a:avLst/>
+            <a:gdLst/>
+            <a:ahLst/>
+            <a:cxnLst/>
+            <a:rect l="l" t="t" r="r" b="b"/>
+            <a:pathLst>
+              <a:path w="5577840" h="367684">
+                <a:moveTo>
+                  <a:pt x="0" y="367684"/>
+                </a:moveTo>
+                <a:lnTo>
+                  <a:pt x="28029" y="366827"/>
+                </a:lnTo>
+                <a:lnTo>
+                  <a:pt x="56058" y="365949"/>
+                </a:lnTo>
+                <a:lnTo>
+                  <a:pt x="84088" y="365050"/>
+                </a:lnTo>
+                <a:lnTo>
+                  <a:pt x="112117" y="364130"/>
+                </a:lnTo>
+                <a:lnTo>
+                  <a:pt x="140146" y="363190"/>
+                </a:lnTo>
+                <a:lnTo>
+                  <a:pt x="168176" y="362230"/>
+                </a:lnTo>
+                <a:lnTo>
+                  <a:pt x="196205" y="361249"/>
+                </a:lnTo>
+                <a:lnTo>
+                  <a:pt x="224234" y="360248"/>
+                </a:lnTo>
+                <a:lnTo>
+                  <a:pt x="252264" y="359226"/>
+                </a:lnTo>
+                <a:lnTo>
+                  <a:pt x="280293" y="358184"/>
+                </a:lnTo>
+                <a:lnTo>
+                  <a:pt x="308322" y="357122"/>
+                </a:lnTo>
+                <a:lnTo>
+                  <a:pt x="336352" y="356040"/>
+                </a:lnTo>
+                <a:lnTo>
+                  <a:pt x="364381" y="354938"/>
+                </a:lnTo>
+                <a:lnTo>
+                  <a:pt x="392410" y="353816"/>
+                </a:lnTo>
+                <a:lnTo>
+                  <a:pt x="420440" y="352674"/>
+                </a:lnTo>
+                <a:lnTo>
+                  <a:pt x="448469" y="351512"/>
+                </a:lnTo>
+                <a:lnTo>
+                  <a:pt x="476498" y="350331"/>
+                </a:lnTo>
+                <a:lnTo>
+                  <a:pt x="504528" y="349130"/>
+                </a:lnTo>
+                <a:lnTo>
+                  <a:pt x="532557" y="347909"/>
+                </a:lnTo>
+                <a:lnTo>
+                  <a:pt x="560586" y="346669"/>
+                </a:lnTo>
+                <a:lnTo>
+                  <a:pt x="588616" y="345410"/>
+                </a:lnTo>
+                <a:lnTo>
+                  <a:pt x="616645" y="344132"/>
+                </a:lnTo>
+                <a:lnTo>
+                  <a:pt x="644674" y="342835"/>
+                </a:lnTo>
+                <a:lnTo>
+                  <a:pt x="672704" y="341519"/>
+                </a:lnTo>
+                <a:lnTo>
+                  <a:pt x="700733" y="340184"/>
+                </a:lnTo>
+                <a:lnTo>
+                  <a:pt x="728763" y="338830"/>
+                </a:lnTo>
+                <a:lnTo>
+                  <a:pt x="756792" y="337457"/>
+                </a:lnTo>
+                <a:lnTo>
+                  <a:pt x="784821" y="336067"/>
+                </a:lnTo>
+                <a:lnTo>
+                  <a:pt x="812851" y="334657"/>
+                </a:lnTo>
+                <a:lnTo>
+                  <a:pt x="840880" y="333230"/>
+                </a:lnTo>
+                <a:lnTo>
+                  <a:pt x="868909" y="331785"/>
+                </a:lnTo>
+                <a:lnTo>
+                  <a:pt x="896939" y="330321"/>
+                </a:lnTo>
+                <a:lnTo>
+                  <a:pt x="924968" y="328840"/>
+                </a:lnTo>
+                <a:lnTo>
+                  <a:pt x="952997" y="327342"/>
+                </a:lnTo>
+                <a:lnTo>
+                  <a:pt x="981027" y="325825"/>
+                </a:lnTo>
+                <a:lnTo>
+                  <a:pt x="1009056" y="324292"/>
+                </a:lnTo>
+                <a:lnTo>
+                  <a:pt x="1037085" y="322741"/>
+                </a:lnTo>
+                <a:lnTo>
+                  <a:pt x="1065115" y="321173"/>
+                </a:lnTo>
+                <a:lnTo>
+                  <a:pt x="1093144" y="319589"/>
+                </a:lnTo>
+                <a:lnTo>
+                  <a:pt x="1121173" y="317988"/>
+                </a:lnTo>
+                <a:lnTo>
+                  <a:pt x="1149203" y="316370"/>
+                </a:lnTo>
+                <a:lnTo>
+                  <a:pt x="1177232" y="314736"/>
+                </a:lnTo>
+                <a:lnTo>
+                  <a:pt x="1205261" y="313085"/>
+                </a:lnTo>
+                <a:lnTo>
+                  <a:pt x="1233291" y="311419"/>
+                </a:lnTo>
+                <a:lnTo>
+                  <a:pt x="1261320" y="309737"/>
+                </a:lnTo>
+                <a:lnTo>
+                  <a:pt x="1289349" y="308039"/>
+                </a:lnTo>
+                <a:lnTo>
+                  <a:pt x="1317379" y="306326"/>
+                </a:lnTo>
+                <a:lnTo>
+                  <a:pt x="1345408" y="304597"/>
+                </a:lnTo>
+                <a:lnTo>
+                  <a:pt x="1373437" y="302853"/>
+                </a:lnTo>
+                <a:lnTo>
+                  <a:pt x="1401467" y="301095"/>
+                </a:lnTo>
+                <a:lnTo>
+                  <a:pt x="1429496" y="299322"/>
+                </a:lnTo>
+                <a:lnTo>
+                  <a:pt x="1457526" y="297534"/>
+                </a:lnTo>
+                <a:lnTo>
+                  <a:pt x="1485555" y="295732"/>
+                </a:lnTo>
+                <a:lnTo>
+                  <a:pt x="1513584" y="293916"/>
+                </a:lnTo>
+                <a:lnTo>
+                  <a:pt x="1541614" y="292086"/>
+                </a:lnTo>
+                <a:lnTo>
+                  <a:pt x="1569643" y="290243"/>
+                </a:lnTo>
+                <a:lnTo>
+                  <a:pt x="1597672" y="288386"/>
+                </a:lnTo>
+                <a:lnTo>
+                  <a:pt x="1625702" y="286516"/>
+                </a:lnTo>
+                <a:lnTo>
+                  <a:pt x="1653731" y="284633"/>
+                </a:lnTo>
+                <a:lnTo>
+                  <a:pt x="1681760" y="282737"/>
+                </a:lnTo>
+                <a:lnTo>
+                  <a:pt x="1709790" y="280829"/>
+                </a:lnTo>
+                <a:lnTo>
+                  <a:pt x="1737819" y="278908"/>
+                </a:lnTo>
+                <a:lnTo>
+                  <a:pt x="1765848" y="276975"/>
+                </a:lnTo>
+                <a:lnTo>
+                  <a:pt x="1793878" y="275030"/>
+                </a:lnTo>
+                <a:lnTo>
+                  <a:pt x="1821907" y="273074"/>
+                </a:lnTo>
+                <a:lnTo>
+                  <a:pt x="1849936" y="271106"/>
+                </a:lnTo>
+                <a:lnTo>
+                  <a:pt x="1877966" y="269127"/>
+                </a:lnTo>
+                <a:lnTo>
+                  <a:pt x="1905995" y="267137"/>
+                </a:lnTo>
+                <a:lnTo>
+                  <a:pt x="1934024" y="265137"/>
+                </a:lnTo>
+                <a:lnTo>
+                  <a:pt x="1962054" y="263126"/>
+                </a:lnTo>
+                <a:lnTo>
+                  <a:pt x="1990083" y="261105"/>
+                </a:lnTo>
+                <a:lnTo>
+                  <a:pt x="2018112" y="259074"/>
+                </a:lnTo>
+                <a:lnTo>
+                  <a:pt x="2046142" y="257033"/>
+                </a:lnTo>
+                <a:lnTo>
+                  <a:pt x="2074171" y="254983"/>
+                </a:lnTo>
+                <a:lnTo>
+                  <a:pt x="2102201" y="252923"/>
+                </a:lnTo>
+                <a:lnTo>
+                  <a:pt x="2130230" y="250855"/>
+                </a:lnTo>
+                <a:lnTo>
+                  <a:pt x="2158259" y="248778"/>
+                </a:lnTo>
+                <a:lnTo>
+                  <a:pt x="2186289" y="246692"/>
+                </a:lnTo>
+                <a:lnTo>
+                  <a:pt x="2214318" y="244599"/>
+                </a:lnTo>
+                <a:lnTo>
+                  <a:pt x="2242347" y="242497"/>
+                </a:lnTo>
+                <a:lnTo>
+                  <a:pt x="2270377" y="240388"/>
+                </a:lnTo>
+                <a:lnTo>
+                  <a:pt x="2298406" y="238271"/>
+                </a:lnTo>
+                <a:lnTo>
+                  <a:pt x="2326435" y="236147"/>
+                </a:lnTo>
+                <a:lnTo>
+                  <a:pt x="2354465" y="234016"/>
+                </a:lnTo>
+                <a:lnTo>
+                  <a:pt x="2382494" y="231879"/>
+                </a:lnTo>
+                <a:lnTo>
+                  <a:pt x="2410523" y="229735"/>
+                </a:lnTo>
+                <a:lnTo>
+                  <a:pt x="2438553" y="227585"/>
+                </a:lnTo>
+                <a:lnTo>
+                  <a:pt x="2466582" y="225429"/>
+                </a:lnTo>
+                <a:lnTo>
+                  <a:pt x="2494611" y="223267"/>
+                </a:lnTo>
+                <a:lnTo>
+                  <a:pt x="2522641" y="221100"/>
+                </a:lnTo>
+                <a:lnTo>
+                  <a:pt x="2550670" y="218928"/>
+                </a:lnTo>
+                <a:lnTo>
+                  <a:pt x="2578699" y="216751"/>
+                </a:lnTo>
+                <a:lnTo>
+                  <a:pt x="2606729" y="214570"/>
+                </a:lnTo>
+                <a:lnTo>
+                  <a:pt x="2634758" y="212384"/>
+                </a:lnTo>
+                <a:lnTo>
+                  <a:pt x="2662787" y="210194"/>
+                </a:lnTo>
+                <a:lnTo>
+                  <a:pt x="2690817" y="208001"/>
+                </a:lnTo>
+                <a:lnTo>
+                  <a:pt x="2718846" y="205803"/>
+                </a:lnTo>
+                <a:lnTo>
+                  <a:pt x="2746875" y="203603"/>
+                </a:lnTo>
+                <a:lnTo>
+                  <a:pt x="2774905" y="201399"/>
+                </a:lnTo>
+                <a:lnTo>
+                  <a:pt x="2802934" y="199193"/>
+                </a:lnTo>
+                <a:lnTo>
+                  <a:pt x="2830964" y="196984"/>
+                </a:lnTo>
+                <a:lnTo>
+                  <a:pt x="2858993" y="194773"/>
+                </a:lnTo>
+                <a:lnTo>
+                  <a:pt x="2887022" y="192560"/>
+                </a:lnTo>
+                <a:lnTo>
+                  <a:pt x="2915052" y="190344"/>
+                </a:lnTo>
+                <a:lnTo>
+                  <a:pt x="2943081" y="188128"/>
+                </a:lnTo>
+                <a:lnTo>
+                  <a:pt x="2971110" y="185910"/>
+                </a:lnTo>
+                <a:lnTo>
+                  <a:pt x="2999140" y="183691"/>
+                </a:lnTo>
+                <a:lnTo>
+                  <a:pt x="3027169" y="181471"/>
+                </a:lnTo>
+                <a:lnTo>
+                  <a:pt x="3055198" y="179251"/>
+                </a:lnTo>
+                <a:lnTo>
+                  <a:pt x="3083228" y="177030"/>
+                </a:lnTo>
+                <a:lnTo>
+                  <a:pt x="3111257" y="174809"/>
+                </a:lnTo>
+                <a:lnTo>
+                  <a:pt x="3139286" y="172589"/>
+                </a:lnTo>
+                <a:lnTo>
+                  <a:pt x="3167316" y="170368"/>
+                </a:lnTo>
+                <a:lnTo>
+                  <a:pt x="3195345" y="168149"/>
+                </a:lnTo>
+                <a:lnTo>
+                  <a:pt x="3223374" y="165930"/>
+                </a:lnTo>
+                <a:lnTo>
+                  <a:pt x="3251404" y="163712"/>
+                </a:lnTo>
+                <a:lnTo>
+                  <a:pt x="3279433" y="161496"/>
+                </a:lnTo>
+                <a:lnTo>
+                  <a:pt x="3307462" y="159281"/>
+                </a:lnTo>
+                <a:lnTo>
+                  <a:pt x="3335492" y="157068"/>
+                </a:lnTo>
+                <a:lnTo>
+                  <a:pt x="3363521" y="154856"/>
+                </a:lnTo>
+                <a:lnTo>
+                  <a:pt x="3391550" y="152647"/>
+                </a:lnTo>
+                <a:lnTo>
+                  <a:pt x="3419580" y="150440"/>
+                </a:lnTo>
+                <a:lnTo>
+                  <a:pt x="3447609" y="148236"/>
+                </a:lnTo>
+                <a:lnTo>
+                  <a:pt x="3475638" y="146035"/>
+                </a:lnTo>
+                <a:lnTo>
+                  <a:pt x="3503668" y="143837"/>
+                </a:lnTo>
+                <a:lnTo>
+                  <a:pt x="3531697" y="141642"/>
+                </a:lnTo>
+                <a:lnTo>
+                  <a:pt x="3559727" y="139450"/>
+                </a:lnTo>
+                <a:lnTo>
+                  <a:pt x="3587756" y="137262"/>
+                </a:lnTo>
+                <a:lnTo>
+                  <a:pt x="3615785" y="135078"/>
+                </a:lnTo>
+                <a:lnTo>
+                  <a:pt x="3643815" y="132897"/>
+                </a:lnTo>
+                <a:lnTo>
+                  <a:pt x="3671844" y="130721"/>
+                </a:lnTo>
+                <a:lnTo>
+                  <a:pt x="3699873" y="128550"/>
+                </a:lnTo>
+                <a:lnTo>
+                  <a:pt x="3727903" y="126383"/>
+                </a:lnTo>
+                <a:lnTo>
+                  <a:pt x="3755932" y="124220"/>
+                </a:lnTo>
+                <a:lnTo>
+                  <a:pt x="3783961" y="122063"/>
+                </a:lnTo>
+                <a:lnTo>
+                  <a:pt x="3811991" y="119910"/>
+                </a:lnTo>
+                <a:lnTo>
+                  <a:pt x="3840020" y="117763"/>
+                </a:lnTo>
+                <a:lnTo>
+                  <a:pt x="3868049" y="115622"/>
+                </a:lnTo>
+                <a:lnTo>
+                  <a:pt x="3896079" y="113486"/>
+                </a:lnTo>
+                <a:lnTo>
+                  <a:pt x="3924108" y="111355"/>
+                </a:lnTo>
+                <a:lnTo>
+                  <a:pt x="3952137" y="109231"/>
+                </a:lnTo>
+                <a:lnTo>
+                  <a:pt x="3980167" y="107113"/>
+                </a:lnTo>
+                <a:lnTo>
+                  <a:pt x="4008196" y="105001"/>
+                </a:lnTo>
+                <a:lnTo>
+                  <a:pt x="4036225" y="102895"/>
+                </a:lnTo>
+                <a:lnTo>
+                  <a:pt x="4064255" y="100796"/>
+                </a:lnTo>
+                <a:lnTo>
+                  <a:pt x="4092284" y="98703"/>
+                </a:lnTo>
+                <a:lnTo>
+                  <a:pt x="4120313" y="96618"/>
+                </a:lnTo>
+                <a:lnTo>
+                  <a:pt x="4148343" y="94539"/>
+                </a:lnTo>
+                <a:lnTo>
+                  <a:pt x="4176372" y="92467"/>
+                </a:lnTo>
+                <a:lnTo>
+                  <a:pt x="4204402" y="90403"/>
+                </a:lnTo>
+                <a:lnTo>
+                  <a:pt x="4232431" y="88346"/>
+                </a:lnTo>
+                <a:lnTo>
+                  <a:pt x="4260460" y="86296"/>
+                </a:lnTo>
+                <a:lnTo>
+                  <a:pt x="4288490" y="84254"/>
+                </a:lnTo>
+                <a:lnTo>
+                  <a:pt x="4316519" y="82220"/>
+                </a:lnTo>
+                <a:lnTo>
+                  <a:pt x="4344548" y="80193"/>
+                </a:lnTo>
+                <a:lnTo>
+                  <a:pt x="4372578" y="78175"/>
+                </a:lnTo>
+                <a:lnTo>
+                  <a:pt x="4400607" y="76164"/>
+                </a:lnTo>
+                <a:lnTo>
+                  <a:pt x="4428636" y="74162"/>
+                </a:lnTo>
+                <a:lnTo>
+                  <a:pt x="4456666" y="72168"/>
+                </a:lnTo>
+                <a:lnTo>
+                  <a:pt x="4484695" y="70182"/>
+                </a:lnTo>
+                <a:lnTo>
+                  <a:pt x="4512724" y="68205"/>
+                </a:lnTo>
+                <a:lnTo>
+                  <a:pt x="4540754" y="66236"/>
+                </a:lnTo>
+                <a:lnTo>
+                  <a:pt x="4568783" y="64276"/>
+                </a:lnTo>
+                <a:lnTo>
+                  <a:pt x="4596812" y="62325"/>
+                </a:lnTo>
+                <a:lnTo>
+                  <a:pt x="4624842" y="60382"/>
+                </a:lnTo>
+                <a:lnTo>
+                  <a:pt x="4652871" y="58449"/>
+                </a:lnTo>
+                <a:lnTo>
+                  <a:pt x="4680900" y="56524"/>
+                </a:lnTo>
+                <a:lnTo>
+                  <a:pt x="4708930" y="54608"/>
+                </a:lnTo>
+                <a:lnTo>
+                  <a:pt x="4736959" y="52702"/>
+                </a:lnTo>
+                <a:lnTo>
+                  <a:pt x="4764988" y="50804"/>
+                </a:lnTo>
+                <a:lnTo>
+                  <a:pt x="4793018" y="48916"/>
+                </a:lnTo>
+                <a:lnTo>
+                  <a:pt x="4821047" y="47038"/>
+                </a:lnTo>
+                <a:lnTo>
+                  <a:pt x="4849076" y="45168"/>
+                </a:lnTo>
+                <a:lnTo>
+                  <a:pt x="4877106" y="43308"/>
+                </a:lnTo>
+                <a:lnTo>
+                  <a:pt x="4905135" y="41458"/>
+                </a:lnTo>
+                <a:lnTo>
+                  <a:pt x="4933165" y="39617"/>
+                </a:lnTo>
+                <a:lnTo>
+                  <a:pt x="4961194" y="37786"/>
+                </a:lnTo>
+                <a:lnTo>
+                  <a:pt x="4989223" y="35964"/>
+                </a:lnTo>
+                <a:lnTo>
+                  <a:pt x="5017253" y="34152"/>
+                </a:lnTo>
+                <a:lnTo>
+                  <a:pt x="5045282" y="32350"/>
+                </a:lnTo>
+                <a:lnTo>
+                  <a:pt x="5073311" y="30558"/>
+                </a:lnTo>
+                <a:lnTo>
+                  <a:pt x="5101341" y="28775"/>
+                </a:lnTo>
+                <a:lnTo>
+                  <a:pt x="5129370" y="27002"/>
+                </a:lnTo>
+                <a:lnTo>
+                  <a:pt x="5157399" y="25239"/>
+                </a:lnTo>
+                <a:lnTo>
+                  <a:pt x="5185429" y="23487"/>
+                </a:lnTo>
+                <a:lnTo>
+                  <a:pt x="5213458" y="21744"/>
+                </a:lnTo>
+                <a:lnTo>
+                  <a:pt x="5241487" y="20011"/>
+                </a:lnTo>
+                <a:lnTo>
+                  <a:pt x="5269517" y="18288"/>
+                </a:lnTo>
+                <a:lnTo>
+                  <a:pt x="5297546" y="16575"/>
+                </a:lnTo>
+                <a:lnTo>
+                  <a:pt x="5325575" y="14872"/>
+                </a:lnTo>
+                <a:lnTo>
+                  <a:pt x="5353605" y="13179"/>
+                </a:lnTo>
+                <a:lnTo>
+                  <a:pt x="5381634" y="11496"/>
+                </a:lnTo>
+                <a:lnTo>
+                  <a:pt x="5409663" y="9823"/>
+                </a:lnTo>
+                <a:lnTo>
+                  <a:pt x="5437693" y="8161"/>
+                </a:lnTo>
+                <a:lnTo>
+                  <a:pt x="5465722" y="6508"/>
+                </a:lnTo>
+                <a:lnTo>
+                  <a:pt x="5493751" y="4866"/>
+                </a:lnTo>
+                <a:lnTo>
+                  <a:pt x="5521781" y="3234"/>
+                </a:lnTo>
+                <a:lnTo>
+                  <a:pt x="5549810" y="1612"/>
+                </a:lnTo>
+                <a:lnTo>
+                  <a:pt x="5577840" y="0"/>
+                </a:lnTo>
+              </a:path>
+            </a:pathLst>
+          </a:custGeom>
+          <a:noFill/>
+          <a:ln w="38100">
+            <a:solidFill>
+              <a:srgbClr val="7FC8F8"/>
+            </a:solidFill>
+          </a:ln>
+          <a:effectLst/>
+        </p:spPr>
+        <p:txBody>
+          <a:bodyPr rtlCol="0" anchor="ctr"/>
+          <a:lstStyle/>
+          <a:p>
+            <a:pPr algn="ctr"/>
+          </a:p>
+        </p:txBody>
+      </p:sp>
+      <p:sp>
+        <p:nvSpPr>
+          <p:cNvPr id="61" name="A-E01 polygon 59" descr="sci-ppt:o059"/>
+          <p:cNvSpPr/>
+          <p:nvPr/>
+        </p:nvSpPr>
+        <p:spPr>
+          <a:xfrm>
+            <a:off x="6126480" y="4419600"/>
+            <a:ext cx="5577840" cy="0"/>
+          </a:xfrm>
+          <a:custGeom>
+            <a:avLst/>
+            <a:gdLst/>
+            <a:ahLst/>
+            <a:cxnLst/>
+            <a:rect l="l" t="t" r="r" b="b"/>
+            <a:pathLst>
+              <a:path w="5577840" h="0">
+                <a:moveTo>
+                  <a:pt x="0" y="0"/>
+                </a:moveTo>
+                <a:lnTo>
+                  <a:pt x="28029" y="0"/>
+                </a:lnTo>
+                <a:lnTo>
+                  <a:pt x="56058" y="0"/>
+                </a:lnTo>
+                <a:lnTo>
+                  <a:pt x="84088" y="0"/>
+                </a:lnTo>
+                <a:lnTo>
+                  <a:pt x="112117" y="0"/>
+                </a:lnTo>
+                <a:lnTo>
+                  <a:pt x="140146" y="0"/>
+                </a:lnTo>
+                <a:lnTo>
+                  <a:pt x="168176" y="0"/>
+                </a:lnTo>
+                <a:lnTo>
+                  <a:pt x="196205" y="0"/>
+                </a:lnTo>
+                <a:lnTo>
+                  <a:pt x="224234" y="0"/>
+                </a:lnTo>
+                <a:lnTo>
+                  <a:pt x="252264" y="0"/>
+                </a:lnTo>
+                <a:lnTo>
+                  <a:pt x="280293" y="0"/>
+                </a:lnTo>
+                <a:lnTo>
+                  <a:pt x="308322" y="0"/>
+                </a:lnTo>
+                <a:lnTo>
+                  <a:pt x="336352" y="0"/>
+                </a:lnTo>
+                <a:lnTo>
+                  <a:pt x="364381" y="0"/>
+                </a:lnTo>
+                <a:lnTo>
+                  <a:pt x="392410" y="0"/>
+                </a:lnTo>
+                <a:lnTo>
+                  <a:pt x="420440" y="0"/>
+                </a:lnTo>
+                <a:lnTo>
+                  <a:pt x="448469" y="0"/>
+                </a:lnTo>
+                <a:lnTo>
+                  <a:pt x="476498" y="0"/>
+                </a:lnTo>
+                <a:lnTo>
+                  <a:pt x="504528" y="0"/>
+                </a:lnTo>
+                <a:lnTo>
+                  <a:pt x="532557" y="0"/>
+                </a:lnTo>
+                <a:lnTo>
+                  <a:pt x="560586" y="0"/>
+                </a:lnTo>
+                <a:lnTo>
+                  <a:pt x="588616" y="0"/>
+                </a:lnTo>
+                <a:lnTo>
+                  <a:pt x="616645" y="0"/>
+                </a:lnTo>
+                <a:lnTo>
+                  <a:pt x="644674" y="0"/>
+                </a:lnTo>
+                <a:lnTo>
+                  <a:pt x="672704" y="0"/>
+                </a:lnTo>
+                <a:lnTo>
+                  <a:pt x="700733" y="0"/>
+                </a:lnTo>
+                <a:lnTo>
+                  <a:pt x="728763" y="0"/>
+                </a:lnTo>
+                <a:lnTo>
+                  <a:pt x="756792" y="0"/>
+                </a:lnTo>
+                <a:lnTo>
+                  <a:pt x="784821" y="0"/>
+                </a:lnTo>
+                <a:lnTo>
+                  <a:pt x="812851" y="0"/>
+                </a:lnTo>
+                <a:lnTo>
+                  <a:pt x="840880" y="0"/>
+                </a:lnTo>
+                <a:lnTo>
+                  <a:pt x="868909" y="0"/>
+                </a:lnTo>
+                <a:lnTo>
+                  <a:pt x="896939" y="0"/>
+                </a:lnTo>
+                <a:lnTo>
+                  <a:pt x="924968" y="0"/>
+                </a:lnTo>
+                <a:lnTo>
+                  <a:pt x="952997" y="0"/>
+                </a:lnTo>
+                <a:lnTo>
+                  <a:pt x="981027" y="0"/>
+                </a:lnTo>
+                <a:lnTo>
+                  <a:pt x="1009056" y="0"/>
+                </a:lnTo>
+                <a:lnTo>
+                  <a:pt x="1037085" y="0"/>
+                </a:lnTo>
+                <a:lnTo>
+                  <a:pt x="1065115" y="0"/>
+                </a:lnTo>
+                <a:lnTo>
+                  <a:pt x="1093144" y="0"/>
+                </a:lnTo>
+                <a:lnTo>
+                  <a:pt x="1121173" y="0"/>
+                </a:lnTo>
+                <a:lnTo>
+                  <a:pt x="1149203" y="0"/>
+                </a:lnTo>
+                <a:lnTo>
+                  <a:pt x="1177232" y="0"/>
+                </a:lnTo>
+                <a:lnTo>
+                  <a:pt x="1205261" y="0"/>
+                </a:lnTo>
+                <a:lnTo>
+                  <a:pt x="1233291" y="0"/>
+                </a:lnTo>
+                <a:lnTo>
+                  <a:pt x="1261320" y="0"/>
+                </a:lnTo>
+                <a:lnTo>
+                  <a:pt x="1289349" y="0"/>
+                </a:lnTo>
+                <a:lnTo>
+                  <a:pt x="1317379" y="0"/>
+                </a:lnTo>
+                <a:lnTo>
+                  <a:pt x="1345408" y="0"/>
+                </a:lnTo>
+                <a:lnTo>
+                  <a:pt x="1373437" y="0"/>
+                </a:lnTo>
+                <a:lnTo>
+                  <a:pt x="1401467" y="0"/>
+                </a:lnTo>
+                <a:lnTo>
+                  <a:pt x="1429496" y="0"/>
+                </a:lnTo>
+                <a:lnTo>
+                  <a:pt x="1457526" y="0"/>
+                </a:lnTo>
+                <a:lnTo>
+                  <a:pt x="1485555" y="0"/>
+                </a:lnTo>
+                <a:lnTo>
+                  <a:pt x="1513584" y="0"/>
+                </a:lnTo>
+                <a:lnTo>
+                  <a:pt x="1541614" y="0"/>
+                </a:lnTo>
+                <a:lnTo>
+                  <a:pt x="1569643" y="0"/>
+                </a:lnTo>
+                <a:lnTo>
+                  <a:pt x="1597672" y="0"/>
+                </a:lnTo>
+                <a:lnTo>
+                  <a:pt x="1625702" y="0"/>
+                </a:lnTo>
+                <a:lnTo>
+                  <a:pt x="1653731" y="0"/>
+                </a:lnTo>
+                <a:lnTo>
+                  <a:pt x="1681760" y="0"/>
+                </a:lnTo>
+                <a:lnTo>
+                  <a:pt x="1709790" y="0"/>
+                </a:lnTo>
+                <a:lnTo>
+                  <a:pt x="1737819" y="0"/>
+                </a:lnTo>
+                <a:lnTo>
+                  <a:pt x="1765848" y="0"/>
+                </a:lnTo>
+                <a:lnTo>
+                  <a:pt x="1793878" y="0"/>
+                </a:lnTo>
+                <a:lnTo>
+                  <a:pt x="1821907" y="0"/>
+                </a:lnTo>
+                <a:lnTo>
+                  <a:pt x="1849936" y="0"/>
+                </a:lnTo>
+                <a:lnTo>
+                  <a:pt x="1877966" y="0"/>
+                </a:lnTo>
+                <a:lnTo>
+                  <a:pt x="1905995" y="0"/>
+                </a:lnTo>
+                <a:lnTo>
+                  <a:pt x="1934024" y="0"/>
+                </a:lnTo>
+                <a:lnTo>
+                  <a:pt x="1962054" y="0"/>
+                </a:lnTo>
+                <a:lnTo>
+                  <a:pt x="1990083" y="0"/>
+                </a:lnTo>
+                <a:lnTo>
+                  <a:pt x="2018112" y="0"/>
+                </a:lnTo>
+                <a:lnTo>
+                  <a:pt x="2046142" y="0"/>
+                </a:lnTo>
+                <a:lnTo>
+                  <a:pt x="2074171" y="0"/>
+                </a:lnTo>
+                <a:lnTo>
+                  <a:pt x="2102201" y="0"/>
+                </a:lnTo>
+                <a:lnTo>
+                  <a:pt x="2130230" y="0"/>
+                </a:lnTo>
+                <a:lnTo>
+                  <a:pt x="2158259" y="0"/>
+                </a:lnTo>
+                <a:lnTo>
+                  <a:pt x="2186289" y="0"/>
+                </a:lnTo>
+                <a:lnTo>
+                  <a:pt x="2214318" y="0"/>
+                </a:lnTo>
+                <a:lnTo>
+                  <a:pt x="2242347" y="0"/>
+                </a:lnTo>
+                <a:lnTo>
+                  <a:pt x="2270377" y="0"/>
+                </a:lnTo>
+                <a:lnTo>
+                  <a:pt x="2298406" y="0"/>
+                </a:lnTo>
+                <a:lnTo>
+                  <a:pt x="2326435" y="0"/>
+                </a:lnTo>
+                <a:lnTo>
+                  <a:pt x="2354465" y="0"/>
+                </a:lnTo>
+                <a:lnTo>
+                  <a:pt x="2382494" y="0"/>
+                </a:lnTo>
+                <a:lnTo>
+                  <a:pt x="2410523" y="0"/>
+                </a:lnTo>
+                <a:lnTo>
+                  <a:pt x="2438553" y="0"/>
+                </a:lnTo>
+                <a:lnTo>
+                  <a:pt x="2466582" y="0"/>
+                </a:lnTo>
+                <a:lnTo>
+                  <a:pt x="2494611" y="0"/>
+                </a:lnTo>
+                <a:lnTo>
+                  <a:pt x="2522641" y="0"/>
+                </a:lnTo>
+                <a:lnTo>
+                  <a:pt x="2550670" y="0"/>
+                </a:lnTo>
+                <a:lnTo>
+                  <a:pt x="2578699" y="0"/>
+                </a:lnTo>
+                <a:lnTo>
+                  <a:pt x="2606729" y="0"/>
+                </a:lnTo>
+                <a:lnTo>
+                  <a:pt x="2634758" y="0"/>
+                </a:lnTo>
+                <a:lnTo>
+                  <a:pt x="2662787" y="0"/>
+                </a:lnTo>
+                <a:lnTo>
+                  <a:pt x="2690817" y="0"/>
+                </a:lnTo>
+                <a:lnTo>
+                  <a:pt x="2718846" y="0"/>
+                </a:lnTo>
+                <a:lnTo>
+                  <a:pt x="2746875" y="0"/>
+                </a:lnTo>
+                <a:lnTo>
+                  <a:pt x="2774905" y="0"/>
+                </a:lnTo>
+                <a:lnTo>
+                  <a:pt x="2802934" y="0"/>
+                </a:lnTo>
+                <a:lnTo>
+                  <a:pt x="2830964" y="0"/>
+                </a:lnTo>
+                <a:lnTo>
+                  <a:pt x="2858993" y="0"/>
+                </a:lnTo>
+                <a:lnTo>
+                  <a:pt x="2887022" y="0"/>
+                </a:lnTo>
+                <a:lnTo>
+                  <a:pt x="2915052" y="0"/>
+                </a:lnTo>
+                <a:lnTo>
+                  <a:pt x="2943081" y="0"/>
+                </a:lnTo>
+                <a:lnTo>
+                  <a:pt x="2971110" y="0"/>
+                </a:lnTo>
+                <a:lnTo>
+                  <a:pt x="2999140" y="0"/>
+                </a:lnTo>
+                <a:lnTo>
+                  <a:pt x="3027169" y="0"/>
+                </a:lnTo>
+                <a:lnTo>
+                  <a:pt x="3055198" y="0"/>
+                </a:lnTo>
+                <a:lnTo>
+                  <a:pt x="3083228" y="0"/>
+                </a:lnTo>
+                <a:lnTo>
+                  <a:pt x="3111257" y="0"/>
+                </a:lnTo>
+                <a:lnTo>
+                  <a:pt x="3139286" y="0"/>
+                </a:lnTo>
+                <a:lnTo>
+                  <a:pt x="3167316" y="0"/>
+                </a:lnTo>
+                <a:lnTo>
+                  <a:pt x="3195345" y="0"/>
+                </a:lnTo>
+                <a:lnTo>
+                  <a:pt x="3223374" y="0"/>
+                </a:lnTo>
+                <a:lnTo>
+                  <a:pt x="3251404" y="0"/>
+                </a:lnTo>
+                <a:lnTo>
+                  <a:pt x="3279433" y="0"/>
+                </a:lnTo>
+                <a:lnTo>
+                  <a:pt x="3307462" y="0"/>
+                </a:lnTo>
+                <a:lnTo>
+                  <a:pt x="3335492" y="0"/>
+                </a:lnTo>
+                <a:lnTo>
+                  <a:pt x="3363521" y="0"/>
+                </a:lnTo>
+                <a:lnTo>
+                  <a:pt x="3391550" y="0"/>
+                </a:lnTo>
+                <a:lnTo>
+                  <a:pt x="3419580" y="0"/>
+                </a:lnTo>
+                <a:lnTo>
+                  <a:pt x="3447609" y="0"/>
+                </a:lnTo>
+                <a:lnTo>
+                  <a:pt x="3475638" y="0"/>
+                </a:lnTo>
+                <a:lnTo>
+                  <a:pt x="3503668" y="0"/>
+                </a:lnTo>
+                <a:lnTo>
+                  <a:pt x="3531697" y="0"/>
+                </a:lnTo>
+                <a:lnTo>
+                  <a:pt x="3559727" y="0"/>
+                </a:lnTo>
+                <a:lnTo>
+                  <a:pt x="3587756" y="0"/>
+                </a:lnTo>
+                <a:lnTo>
+                  <a:pt x="3615785" y="0"/>
+                </a:lnTo>
+                <a:lnTo>
+                  <a:pt x="3643815" y="0"/>
+                </a:lnTo>
+                <a:lnTo>
+                  <a:pt x="3671844" y="0"/>
+                </a:lnTo>
+                <a:lnTo>
+                  <a:pt x="3699873" y="0"/>
+                </a:lnTo>
+                <a:lnTo>
+                  <a:pt x="3727903" y="0"/>
+                </a:lnTo>
+                <a:lnTo>
+                  <a:pt x="3755932" y="0"/>
+                </a:lnTo>
+                <a:lnTo>
+                  <a:pt x="3783961" y="0"/>
+                </a:lnTo>
+                <a:lnTo>
+                  <a:pt x="3811991" y="0"/>
+                </a:lnTo>
+                <a:lnTo>
+                  <a:pt x="3840020" y="0"/>
+                </a:lnTo>
+                <a:lnTo>
+                  <a:pt x="3868049" y="0"/>
+                </a:lnTo>
+                <a:lnTo>
+                  <a:pt x="3896079" y="0"/>
+                </a:lnTo>
+                <a:lnTo>
+                  <a:pt x="3924108" y="0"/>
+                </a:lnTo>
+                <a:lnTo>
+                  <a:pt x="3952137" y="0"/>
+                </a:lnTo>
+                <a:lnTo>
+                  <a:pt x="3980167" y="0"/>
+                </a:lnTo>
+                <a:lnTo>
+                  <a:pt x="4008196" y="0"/>
+                </a:lnTo>
+                <a:lnTo>
+                  <a:pt x="4036225" y="0"/>
+                </a:lnTo>
+                <a:lnTo>
+                  <a:pt x="4064255" y="0"/>
+                </a:lnTo>
+                <a:lnTo>
+                  <a:pt x="4092284" y="0"/>
+                </a:lnTo>
+                <a:lnTo>
+                  <a:pt x="4120313" y="0"/>
+                </a:lnTo>
+                <a:lnTo>
+                  <a:pt x="4148343" y="0"/>
+                </a:lnTo>
+                <a:lnTo>
+                  <a:pt x="4176372" y="0"/>
+                </a:lnTo>
+                <a:lnTo>
+                  <a:pt x="4204402" y="0"/>
+                </a:lnTo>
+                <a:lnTo>
+                  <a:pt x="4232431" y="0"/>
+                </a:lnTo>
+                <a:lnTo>
+                  <a:pt x="4260460" y="0"/>
+                </a:lnTo>
+                <a:lnTo>
+                  <a:pt x="4288490" y="0"/>
+                </a:lnTo>
+                <a:lnTo>
+                  <a:pt x="4316519" y="0"/>
+                </a:lnTo>
+                <a:lnTo>
+                  <a:pt x="4344548" y="0"/>
+                </a:lnTo>
+                <a:lnTo>
+                  <a:pt x="4372578" y="0"/>
+                </a:lnTo>
+                <a:lnTo>
+                  <a:pt x="4400607" y="0"/>
+                </a:lnTo>
+                <a:lnTo>
+                  <a:pt x="4428636" y="0"/>
+                </a:lnTo>
+                <a:lnTo>
+                  <a:pt x="4456666" y="0"/>
+                </a:lnTo>
+                <a:lnTo>
+                  <a:pt x="4484695" y="0"/>
+                </a:lnTo>
+                <a:lnTo>
+                  <a:pt x="4512724" y="0"/>
+                </a:lnTo>
+                <a:lnTo>
+                  <a:pt x="4540754" y="0"/>
+                </a:lnTo>
+                <a:lnTo>
+                  <a:pt x="4568783" y="0"/>
+                </a:lnTo>
+                <a:lnTo>
+                  <a:pt x="4596812" y="0"/>
+                </a:lnTo>
+                <a:lnTo>
+                  <a:pt x="4624842" y="0"/>
+                </a:lnTo>
+                <a:lnTo>
+                  <a:pt x="4652871" y="0"/>
+                </a:lnTo>
+                <a:lnTo>
+                  <a:pt x="4680900" y="0"/>
+                </a:lnTo>
+                <a:lnTo>
+                  <a:pt x="4708930" y="0"/>
+                </a:lnTo>
+                <a:lnTo>
+                  <a:pt x="4736959" y="0"/>
+                </a:lnTo>
+                <a:lnTo>
+                  <a:pt x="4764988" y="0"/>
+                </a:lnTo>
+                <a:lnTo>
+                  <a:pt x="4793018" y="0"/>
+                </a:lnTo>
+                <a:lnTo>
+                  <a:pt x="4821047" y="0"/>
+                </a:lnTo>
+                <a:lnTo>
+                  <a:pt x="4849076" y="0"/>
+                </a:lnTo>
+                <a:lnTo>
+                  <a:pt x="4877106" y="0"/>
+                </a:lnTo>
+                <a:lnTo>
+                  <a:pt x="4905135" y="0"/>
+                </a:lnTo>
+                <a:lnTo>
+                  <a:pt x="4933165" y="0"/>
+                </a:lnTo>
+                <a:lnTo>
+                  <a:pt x="4961194" y="0"/>
+                </a:lnTo>
+                <a:lnTo>
+                  <a:pt x="4989223" y="0"/>
+                </a:lnTo>
+                <a:lnTo>
+                  <a:pt x="5017253" y="0"/>
+                </a:lnTo>
+                <a:lnTo>
+                  <a:pt x="5045282" y="0"/>
+                </a:lnTo>
+                <a:lnTo>
+                  <a:pt x="5073311" y="0"/>
+                </a:lnTo>
+                <a:lnTo>
+                  <a:pt x="5101341" y="0"/>
+                </a:lnTo>
+                <a:lnTo>
+                  <a:pt x="5129370" y="0"/>
+                </a:lnTo>
+                <a:lnTo>
+                  <a:pt x="5157399" y="0"/>
+                </a:lnTo>
+                <a:lnTo>
+                  <a:pt x="5185429" y="0"/>
+                </a:lnTo>
+                <a:lnTo>
+                  <a:pt x="5213458" y="0"/>
+                </a:lnTo>
+                <a:lnTo>
+                  <a:pt x="5241487" y="0"/>
+                </a:lnTo>
+                <a:lnTo>
+                  <a:pt x="5269517" y="0"/>
+                </a:lnTo>
+                <a:lnTo>
+                  <a:pt x="5297546" y="0"/>
+                </a:lnTo>
+                <a:lnTo>
+                  <a:pt x="5325575" y="0"/>
+                </a:lnTo>
+                <a:lnTo>
+                  <a:pt x="5353605" y="0"/>
+                </a:lnTo>
+                <a:lnTo>
+                  <a:pt x="5381634" y="0"/>
+                </a:lnTo>
+                <a:lnTo>
+                  <a:pt x="5409663" y="0"/>
+                </a:lnTo>
+                <a:lnTo>
+                  <a:pt x="5437693" y="0"/>
+                </a:lnTo>
+                <a:lnTo>
+                  <a:pt x="5465722" y="0"/>
+                </a:lnTo>
+                <a:lnTo>
+                  <a:pt x="5493751" y="0"/>
+                </a:lnTo>
+                <a:lnTo>
+                  <a:pt x="5521781" y="0"/>
+                </a:lnTo>
+                <a:lnTo>
+                  <a:pt x="5549810" y="0"/>
+                </a:lnTo>
+                <a:lnTo>
+                  <a:pt x="5577840" y="0"/>
+                </a:lnTo>
+              </a:path>
+            </a:pathLst>
+          </a:custGeom>
+          <a:noFill/>
+          <a:ln w="25400">
+            <a:solidFill>
+              <a:srgbClr val="E7F0F3"/>
+            </a:solidFill>
+            <a:prstDash val="dash"/>
+          </a:ln>
+          <a:effectLst/>
+        </p:spPr>
+        <p:txBody>
+          <a:bodyPr rtlCol="0" anchor="ctr"/>
+          <a:lstStyle/>
+          <a:p>
+            <a:pPr algn="ctr"/>
+          </a:p>
+        </p:txBody>
+      </p:sp>
+      <p:sp>
+        <p:nvSpPr>
+          <p:cNvPr id="62" name="A-E01 text 60" descr="sci-ppt:o060"/>
           <p:cNvSpPr txBox="1"/>
           <p:nvPr/>
         </p:nvSpPr>
         <p:spPr>
           <a:xfrm>
-            <a:off x="6373368" y="2231136"/>
-            <a:ext cx="640080" cy="310896"/>
+            <a:off x="7538313" y="1981199"/>
+            <a:ext cx="3108960" cy="223900"/>
           </a:xfrm>
           <a:prstGeom prst="rect">
             <a:avLst/>
@@ -3494,7 +6740,7 @@
           <a:effectLst/>
         </p:spPr>
         <p:txBody>
-          <a:bodyPr wrap="none" lIns="0" rIns="0" tIns="0" bIns="0" anchor="ctr">
+          <a:bodyPr wrap="none" lIns="18288" rIns="18288" tIns="18288" bIns="18288" anchor="t">
             <a:spAutoFit/>
           </a:bodyPr>
           <a:lstStyle/>
@@ -3505,51 +6751,107 @@
               </a:spcAft>
             </a:pPr>
             <a:r>
-              <a:rPr sz="1296" b="0" i="0">
+              <a:rPr sz="1150" b="0" i="0">
+                <a:solidFill>
+                  <a:srgbClr val="F2B880"/>
+                </a:solidFill>
+                <a:latin typeface="Arial"/>
+              </a:rPr>
+              <a:t>λ_θ = λᵩ (tangential): stretched</a:t>
+            </a:r>
+          </a:p>
+        </p:txBody>
+      </p:sp>
+      <p:sp>
+        <p:nvSpPr>
+          <p:cNvPr id="63" name="A-E01 text 61" descr="sci-ppt:o061"/>
+          <p:cNvSpPr txBox="1"/>
+          <p:nvPr/>
+        </p:nvSpPr>
+        <p:spPr>
+          <a:xfrm>
+            <a:off x="8653881" y="3688080"/>
+            <a:ext cx="2377440" cy="223900"/>
+          </a:xfrm>
+          <a:prstGeom prst="rect">
+            <a:avLst/>
+          </a:prstGeom>
+          <a:noFill/>
+          <a:effectLst/>
+        </p:spPr>
+        <p:txBody>
+          <a:bodyPr wrap="none" lIns="18288" rIns="18288" tIns="18288" bIns="18288" anchor="t">
+            <a:spAutoFit/>
+          </a:bodyPr>
+          <a:lstStyle/>
+          <a:p>
+            <a:pPr algn="l">
+              <a:spcAft>
+                <a:spcPts val="0"/>
+              </a:spcAft>
+            </a:pPr>
+            <a:r>
+              <a:rPr sz="1150" b="0" i="0">
+                <a:solidFill>
+                  <a:srgbClr val="7FC8F8"/>
+                </a:solidFill>
+                <a:latin typeface="Arial"/>
+              </a:rPr>
+              <a:t>λᵣ (radial): thinned</a:t>
+            </a:r>
+          </a:p>
+        </p:txBody>
+      </p:sp>
+      <p:sp>
+        <p:nvSpPr>
+          <p:cNvPr id="64" name="A-E01 text 62" descr="sci-ppt:o062"/>
+          <p:cNvSpPr txBox="1"/>
+          <p:nvPr/>
+        </p:nvSpPr>
+        <p:spPr>
+          <a:xfrm>
+            <a:off x="8430768" y="4572000"/>
+            <a:ext cx="2743200" cy="223900"/>
+          </a:xfrm>
+          <a:prstGeom prst="rect">
+            <a:avLst/>
+          </a:prstGeom>
+          <a:noFill/>
+          <a:effectLst/>
+        </p:spPr>
+        <p:txBody>
+          <a:bodyPr wrap="none" lIns="18288" rIns="18288" tIns="18288" bIns="18288" anchor="t">
+            <a:spAutoFit/>
+          </a:bodyPr>
+          <a:lstStyle/>
+          <a:p>
+            <a:pPr algn="l">
+              <a:spcAft>
+                <a:spcPts val="0"/>
+              </a:spcAft>
+            </a:pPr>
+            <a:r>
+              <a:rPr sz="1150" b="0" i="0">
                 <a:solidFill>
                   <a:srgbClr val="E7F0F3"/>
                 </a:solidFill>
                 <a:latin typeface="Arial"/>
               </a:rPr>
-              <a:t>r</a:t>
-            </a:r>
-          </a:p>
-        </p:txBody>
-      </p:sp>
-      <p:cxnSp>
-        <p:nvCxnSpPr>
-          <p:cNvPr id="15" name="arrow 13" descr="sci-ppt:obj-013"/>
-          <p:cNvCxnSpPr/>
-          <p:nvPr/>
-        </p:nvCxnSpPr>
-        <p:spPr>
-          <a:xfrm>
-            <a:off x="2697480" y="1645920"/>
-            <a:ext cx="1691640" cy="0"/>
-          </a:xfrm>
-          <a:prstGeom prst="line">
-            <a:avLst/>
-          </a:prstGeom>
-          <a:ln w="21590">
-            <a:solidFill>
-              <a:srgbClr val="8EDBD4"/>
-            </a:solidFill>
-            <a:headEnd type="none" w="med" len="med"/>
-            <a:tailEnd type="triangle" w="med" len="med"/>
-          </a:ln>
-          <a:effectLst/>
-        </p:spPr>
-      </p:cxnSp>
-      <p:sp>
-        <p:nvSpPr>
-          <p:cNvPr id="16" name="text 14" descr="sci-ppt:obj-014"/>
+              <a:t>product = 1 (incompressible)</a:t>
+            </a:r>
+          </a:p>
+        </p:txBody>
+      </p:sp>
+      <p:sp>
+        <p:nvSpPr>
+          <p:cNvPr id="65" name="A-E01 text 63" descr="sci-ppt:o063"/>
           <p:cNvSpPr txBox="1"/>
           <p:nvPr/>
         </p:nvSpPr>
         <p:spPr>
           <a:xfrm>
-            <a:off x="2834640" y="1143000"/>
-            <a:ext cx="2286000" cy="310896"/>
+            <a:off x="6126480" y="5852160"/>
+            <a:ext cx="5577840" cy="231648"/>
           </a:xfrm>
           <a:prstGeom prst="rect">
             <a:avLst/>
@@ -3558,7 +6860,7 @@
           <a:effectLst/>
         </p:spPr>
         <p:txBody>
-          <a:bodyPr wrap="none" lIns="0" rIns="0" tIns="0" bIns="0" anchor="ctr">
+          <a:bodyPr wrap="none" lIns="18288" rIns="18288" tIns="18288" bIns="18288" anchor="t">
             <a:spAutoFit/>
           </a:bodyPr>
           <a:lstStyle/>
@@ -3569,27 +6871,27 @@
               </a:spcAft>
             </a:pPr>
             <a:r>
-              <a:rPr sz="1296" b="0" i="0">
+              <a:rPr sz="1200" b="0" i="0">
                 <a:solidFill>
-                  <a:srgbClr val="E7F0F3"/>
+                  <a:srgbClr val="B4C7D2"/>
                 </a:solidFill>
                 <a:latin typeface="Arial"/>
               </a:rPr>
-              <a:t>Material map</a:t>
-            </a:r>
-          </a:p>
-        </p:txBody>
-      </p:sp>
-      <p:sp>
-        <p:nvSpPr>
-          <p:cNvPr id="17" name="text 15" descr="sci-ppt:obj-015"/>
+              <a:t>Check: λ_rλ_θ² = 1.000000 … 1.000000.   Cavity grown from 5 to 30 µm.</a:t>
+            </a:r>
+          </a:p>
+        </p:txBody>
+      </p:sp>
+      <p:sp>
+        <p:nvSpPr>
+          <p:cNvPr id="66" name="A-E01 text 64" descr="sci-ppt:o064"/>
           <p:cNvSpPr txBox="1"/>
           <p:nvPr/>
         </p:nvSpPr>
         <p:spPr>
           <a:xfrm>
-            <a:off x="1005840" y="2578608"/>
-            <a:ext cx="2286000" cy="310896"/>
+            <a:off x="320040" y="6510528"/>
+            <a:ext cx="11521440" cy="200660"/>
           </a:xfrm>
           <a:prstGeom prst="rect">
             <a:avLst/>
@@ -3598,7 +6900,7 @@
           <a:effectLst/>
         </p:spPr>
         <p:txBody>
-          <a:bodyPr wrap="none" lIns="0" rIns="0" tIns="0" bIns="0" anchor="ctr">
+          <a:bodyPr wrap="none" lIns="18288" rIns="18288" tIns="18288" bIns="18288" anchor="t">
             <a:spAutoFit/>
           </a:bodyPr>
           <a:lstStyle/>
@@ -3609,573 +6911,13 @@
               </a:spcAft>
             </a:pPr>
             <a:r>
-              <a:rPr sz="1296" b="0" i="0">
+              <a:rPr sz="1000" b="0" i="0">
                 <a:solidFill>
-                  <a:srgbClr val="E7F0F3"/>
+                  <a:srgbClr val="B4C7D2"/>
                 </a:solidFill>
                 <a:latin typeface="Arial"/>
               </a:rPr>
-              <a:t>Reference</a:t>
-            </a:r>
-          </a:p>
-        </p:txBody>
-      </p:sp>
-      <p:sp>
-        <p:nvSpPr>
-          <p:cNvPr id="18" name="text 16" descr="sci-ppt:obj-016"/>
-          <p:cNvSpPr txBox="1"/>
-          <p:nvPr/>
-        </p:nvSpPr>
-        <p:spPr>
-          <a:xfrm>
-            <a:off x="4846320" y="2660904"/>
-            <a:ext cx="3383280" cy="310896"/>
-          </a:xfrm>
-          <a:prstGeom prst="rect">
-            <a:avLst/>
-          </a:prstGeom>
-          <a:noFill/>
-          <a:effectLst/>
-        </p:spPr>
-        <p:txBody>
-          <a:bodyPr wrap="none" lIns="0" rIns="0" tIns="0" bIns="0" anchor="ctr">
-            <a:spAutoFit/>
-          </a:bodyPr>
-          <a:lstStyle/>
-          <a:p>
-            <a:pPr algn="l">
-              <a:spcAft>
-                <a:spcPts val="0"/>
-              </a:spcAft>
-            </a:pPr>
-            <a:r>
-              <a:rPr sz="1296" b="0" i="0">
-                <a:solidFill>
-                  <a:srgbClr val="E7F0F3"/>
-                </a:solidFill>
-                <a:latin typeface="Arial"/>
-              </a:rPr>
-              <a:t>Deformed: λr , λθ</a:t>
-            </a:r>
-          </a:p>
-        </p:txBody>
-      </p:sp>
-      <p:sp>
-        <p:nvSpPr>
-          <p:cNvPr id="19" name="text 17" descr="sci-ppt:obj-017"/>
-          <p:cNvSpPr txBox="1"/>
-          <p:nvPr/>
-        </p:nvSpPr>
-        <p:spPr>
-          <a:xfrm>
-            <a:off x="6839712" y="777240"/>
-            <a:ext cx="1645920" cy="310896"/>
-          </a:xfrm>
-          <a:prstGeom prst="rect">
-            <a:avLst/>
-          </a:prstGeom>
-          <a:noFill/>
-          <a:effectLst/>
-        </p:spPr>
-        <p:txBody>
-          <a:bodyPr wrap="none" lIns="0" rIns="0" tIns="0" bIns="0" anchor="ctr">
-            <a:spAutoFit/>
-          </a:bodyPr>
-          <a:lstStyle/>
-          <a:p>
-            <a:pPr algn="l">
-              <a:spcAft>
-                <a:spcPts val="0"/>
-              </a:spcAft>
-            </a:pPr>
-            <a:r>
-              <a:rPr sz="1296" b="0" i="0">
-                <a:solidFill>
-                  <a:srgbClr val="E7F0F3"/>
-                </a:solidFill>
-                <a:latin typeface="Arial"/>
-              </a:rPr>
-              <a:t>Gg , ηg</a:t>
-            </a:r>
-          </a:p>
-        </p:txBody>
-      </p:sp>
-      <p:sp>
-        <p:nvSpPr>
-          <p:cNvPr id="20" name="text 18" descr="sci-ppt:obj-018"/>
-          <p:cNvSpPr txBox="1"/>
-          <p:nvPr/>
-        </p:nvSpPr>
-        <p:spPr>
-          <a:xfrm>
-            <a:off x="6839712" y="1207008"/>
-            <a:ext cx="1828800" cy="310896"/>
-          </a:xfrm>
-          <a:prstGeom prst="rect">
-            <a:avLst/>
-          </a:prstGeom>
-          <a:noFill/>
-          <a:effectLst/>
-        </p:spPr>
-        <p:txBody>
-          <a:bodyPr wrap="none" lIns="0" rIns="0" tIns="0" bIns="0" anchor="ctr">
-            <a:spAutoFit/>
-          </a:bodyPr>
-          <a:lstStyle/>
-          <a:p>
-            <a:pPr algn="l">
-              <a:spcAft>
-                <a:spcPts val="0"/>
-              </a:spcAft>
-            </a:pPr>
-            <a:r>
-              <a:rPr sz="1296" b="0" i="0">
-                <a:solidFill>
-                  <a:srgbClr val="E7F0F3"/>
-                </a:solidFill>
-                <a:latin typeface="Arial"/>
-              </a:rPr>
-              <a:t>σrr , σθθ</a:t>
-            </a:r>
-          </a:p>
-        </p:txBody>
-      </p:sp>
-      <p:sp>
-        <p:nvSpPr>
-          <p:cNvPr id="21" name="text 19" descr="sci-ppt:obj-019"/>
-          <p:cNvSpPr txBox="1"/>
-          <p:nvPr/>
-        </p:nvSpPr>
-        <p:spPr>
-          <a:xfrm>
-            <a:off x="6839712" y="1645920"/>
-            <a:ext cx="1371600" cy="310896"/>
-          </a:xfrm>
-          <a:prstGeom prst="rect">
-            <a:avLst/>
-          </a:prstGeom>
-          <a:noFill/>
-          <a:effectLst/>
-        </p:spPr>
-        <p:txBody>
-          <a:bodyPr wrap="none" lIns="0" rIns="0" tIns="0" bIns="0" anchor="ctr">
-            <a:spAutoFit/>
-          </a:bodyPr>
-          <a:lstStyle/>
-          <a:p>
-            <a:pPr algn="l">
-              <a:spcAft>
-                <a:spcPts val="0"/>
-              </a:spcAft>
-            </a:pPr>
-            <a:r>
-              <a:rPr sz="1296" b="0" i="0">
-                <a:solidFill>
-                  <a:srgbClr val="E7F0F3"/>
-                </a:solidFill>
-                <a:latin typeface="Arial"/>
-              </a:rPr>
-              <a:t>p∞</a:t>
-            </a:r>
-          </a:p>
-        </p:txBody>
-      </p:sp>
-      <p:sp>
-        <p:nvSpPr>
-          <p:cNvPr id="22" name="text 20" descr="sci-ppt:obj-020"/>
-          <p:cNvSpPr txBox="1"/>
-          <p:nvPr/>
-        </p:nvSpPr>
-        <p:spPr>
-          <a:xfrm>
-            <a:off x="5266944" y="1682496"/>
-            <a:ext cx="822960" cy="310896"/>
-          </a:xfrm>
-          <a:prstGeom prst="rect">
-            <a:avLst/>
-          </a:prstGeom>
-          <a:noFill/>
-          <a:effectLst/>
-        </p:spPr>
-        <p:txBody>
-          <a:bodyPr wrap="none" lIns="0" rIns="0" tIns="0" bIns="0" anchor="ctr">
-            <a:spAutoFit/>
-          </a:bodyPr>
-          <a:lstStyle/>
-          <a:p>
-            <a:pPr algn="l">
-              <a:spcAft>
-                <a:spcPts val="0"/>
-              </a:spcAft>
-            </a:pPr>
-            <a:r>
-              <a:rPr sz="1296" b="0" i="0">
-                <a:solidFill>
-                  <a:srgbClr val="E7F0F3"/>
-                </a:solidFill>
-                <a:latin typeface="Arial"/>
-              </a:rPr>
-              <a:t>pb</a:t>
-            </a:r>
-          </a:p>
-        </p:txBody>
-      </p:sp>
-      <p:sp>
-        <p:nvSpPr>
-          <p:cNvPr id="23" name="text 21" descr="sci-ppt:obj-021"/>
-          <p:cNvSpPr txBox="1"/>
-          <p:nvPr/>
-        </p:nvSpPr>
-        <p:spPr>
-          <a:xfrm>
-            <a:off x="868680" y="2990088"/>
-            <a:ext cx="7772400" cy="310896"/>
-          </a:xfrm>
-          <a:prstGeom prst="rect">
-            <a:avLst/>
-          </a:prstGeom>
-          <a:noFill/>
-          <a:effectLst/>
-        </p:spPr>
-        <p:txBody>
-          <a:bodyPr wrap="none" lIns="0" rIns="0" tIns="0" bIns="0" anchor="ctr">
-            <a:spAutoFit/>
-          </a:bodyPr>
-          <a:lstStyle/>
-          <a:p>
-            <a:pPr algn="l">
-              <a:spcAft>
-                <a:spcPts val="0"/>
-              </a:spcAft>
-            </a:pPr>
-            <a:r>
-              <a:rPr sz="1152" b="0" i="0">
-                <a:solidFill>
-                  <a:srgbClr val="E7F0F3"/>
-                </a:solidFill>
-                <a:latin typeface="Arial"/>
-              </a:rPr>
-              <a:t>r₀³ − Rref³ = r³ − R³ ; radial coordinates point outward</a:t>
-            </a:r>
-          </a:p>
-        </p:txBody>
-      </p:sp>
-      <p:sp>
-        <p:nvSpPr>
-          <p:cNvPr id="24" name="text 22" descr="sci-ppt:obj-022"/>
-          <p:cNvSpPr txBox="1"/>
-          <p:nvPr/>
-        </p:nvSpPr>
-        <p:spPr>
-          <a:xfrm>
-            <a:off x="256032" y="3465576"/>
-            <a:ext cx="7315200" cy="310896"/>
-          </a:xfrm>
-          <a:prstGeom prst="rect">
-            <a:avLst/>
-          </a:prstGeom>
-          <a:noFill/>
-          <a:effectLst/>
-        </p:spPr>
-        <p:txBody>
-          <a:bodyPr wrap="none" lIns="0" rIns="0" tIns="0" bIns="0" anchor="ctr">
-            <a:spAutoFit/>
-          </a:bodyPr>
-          <a:lstStyle/>
-          <a:p>
-            <a:pPr algn="l">
-              <a:spcAft>
-                <a:spcPts val="0"/>
-              </a:spcAft>
-            </a:pPr>
-            <a:r>
-              <a:rPr sz="1296" b="0" i="0">
-                <a:solidFill>
-                  <a:srgbClr val="8EDBD4"/>
-                </a:solidFill>
-                <a:latin typeface="Arial"/>
-              </a:rPr>
-              <a:t>Variables and physical limits</a:t>
-            </a:r>
-          </a:p>
-        </p:txBody>
-      </p:sp>
-      <p:sp>
-        <p:nvSpPr>
-          <p:cNvPr id="25" name="text 23" descr="sci-ppt:obj-023"/>
-          <p:cNvSpPr txBox="1"/>
-          <p:nvPr/>
-        </p:nvSpPr>
-        <p:spPr>
-          <a:xfrm>
-            <a:off x="365760" y="3813048"/>
-            <a:ext cx="8412480" cy="310896"/>
-          </a:xfrm>
-          <a:prstGeom prst="rect">
-            <a:avLst/>
-          </a:prstGeom>
-          <a:noFill/>
-          <a:effectLst/>
-        </p:spPr>
-        <p:txBody>
-          <a:bodyPr wrap="none" lIns="0" rIns="0" tIns="0" bIns="0" anchor="ctr">
-            <a:spAutoFit/>
-          </a:bodyPr>
-          <a:lstStyle/>
-          <a:p>
-            <a:pPr algn="l">
-              <a:spcAft>
-                <a:spcPts val="0"/>
-              </a:spcAft>
-            </a:pPr>
-            <a:r>
-              <a:rPr sz="1152" b="0" i="0">
-                <a:solidFill>
-                  <a:srgbClr val="E7F0F3"/>
-                </a:solidFill>
-                <a:latin typeface="Arial"/>
-              </a:rPr>
-              <a:t>• Rref: reference wall</a:t>
-            </a:r>
-          </a:p>
-        </p:txBody>
-      </p:sp>
-      <p:sp>
-        <p:nvSpPr>
-          <p:cNvPr id="26" name="text 24" descr="sci-ppt:obj-024"/>
-          <p:cNvSpPr txBox="1"/>
-          <p:nvPr/>
-        </p:nvSpPr>
-        <p:spPr>
-          <a:xfrm>
-            <a:off x="365760" y="4023360"/>
-            <a:ext cx="8412480" cy="310896"/>
-          </a:xfrm>
-          <a:prstGeom prst="rect">
-            <a:avLst/>
-          </a:prstGeom>
-          <a:noFill/>
-          <a:effectLst/>
-        </p:spPr>
-        <p:txBody>
-          <a:bodyPr wrap="none" lIns="0" rIns="0" tIns="0" bIns="0" anchor="ctr">
-            <a:spAutoFit/>
-          </a:bodyPr>
-          <a:lstStyle/>
-          <a:p>
-            <a:pPr algn="l">
-              <a:spcAft>
-                <a:spcPts val="0"/>
-              </a:spcAft>
-            </a:pPr>
-            <a:r>
-              <a:rPr sz="1152" b="0" i="0">
-                <a:solidFill>
-                  <a:srgbClr val="E7F0F3"/>
-                </a:solidFill>
-                <a:latin typeface="Arial"/>
-              </a:rPr>
-              <a:t>• R: current wall</a:t>
-            </a:r>
-          </a:p>
-        </p:txBody>
-      </p:sp>
-      <p:sp>
-        <p:nvSpPr>
-          <p:cNvPr id="27" name="text 25" descr="sci-ppt:obj-025"/>
-          <p:cNvSpPr txBox="1"/>
-          <p:nvPr/>
-        </p:nvSpPr>
-        <p:spPr>
-          <a:xfrm>
-            <a:off x="365760" y="4233672"/>
-            <a:ext cx="8412480" cy="310896"/>
-          </a:xfrm>
-          <a:prstGeom prst="rect">
-            <a:avLst/>
-          </a:prstGeom>
-          <a:noFill/>
-          <a:effectLst/>
-        </p:spPr>
-        <p:txBody>
-          <a:bodyPr wrap="none" lIns="0" rIns="0" tIns="0" bIns="0" anchor="ctr">
-            <a:spAutoFit/>
-          </a:bodyPr>
-          <a:lstStyle/>
-          <a:p>
-            <a:pPr algn="l">
-              <a:spcAft>
-                <a:spcPts val="0"/>
-              </a:spcAft>
-            </a:pPr>
-            <a:r>
-              <a:rPr sz="1152" b="0" i="0">
-                <a:solidFill>
-                  <a:srgbClr val="E7F0F3"/>
-                </a:solidFill>
-                <a:latin typeface="Arial"/>
-              </a:rPr>
-              <a:t>• r₀ → r: material shell</a:t>
-            </a:r>
-          </a:p>
-        </p:txBody>
-      </p:sp>
-      <p:sp>
-        <p:nvSpPr>
-          <p:cNvPr id="28" name="text 26" descr="sci-ppt:obj-026"/>
-          <p:cNvSpPr txBox="1"/>
-          <p:nvPr/>
-        </p:nvSpPr>
-        <p:spPr>
-          <a:xfrm>
-            <a:off x="365760" y="4443984"/>
-            <a:ext cx="8412480" cy="310896"/>
-          </a:xfrm>
-          <a:prstGeom prst="rect">
-            <a:avLst/>
-          </a:prstGeom>
-          <a:noFill/>
-          <a:effectLst/>
-        </p:spPr>
-        <p:txBody>
-          <a:bodyPr wrap="none" lIns="0" rIns="0" tIns="0" bIns="0" anchor="ctr">
-            <a:spAutoFit/>
-          </a:bodyPr>
-          <a:lstStyle/>
-          <a:p>
-            <a:pPr algn="l">
-              <a:spcAft>
-                <a:spcPts val="0"/>
-              </a:spcAft>
-            </a:pPr>
-            <a:r>
-              <a:rPr sz="1152" b="0" i="0">
-                <a:solidFill>
-                  <a:srgbClr val="E7F0F3"/>
-                </a:solidFill>
-                <a:latin typeface="Arial"/>
-              </a:rPr>
-              <a:t>• λr = r₀²/r²</a:t>
-            </a:r>
-          </a:p>
-        </p:txBody>
-      </p:sp>
-      <p:sp>
-        <p:nvSpPr>
-          <p:cNvPr id="29" name="text 27" descr="sci-ppt:obj-027"/>
-          <p:cNvSpPr txBox="1"/>
-          <p:nvPr/>
-        </p:nvSpPr>
-        <p:spPr>
-          <a:xfrm>
-            <a:off x="365760" y="4654296"/>
-            <a:ext cx="8412480" cy="310896"/>
-          </a:xfrm>
-          <a:prstGeom prst="rect">
-            <a:avLst/>
-          </a:prstGeom>
-          <a:noFill/>
-          <a:effectLst/>
-        </p:spPr>
-        <p:txBody>
-          <a:bodyPr wrap="none" lIns="0" rIns="0" tIns="0" bIns="0" anchor="ctr">
-            <a:spAutoFit/>
-          </a:bodyPr>
-          <a:lstStyle/>
-          <a:p>
-            <a:pPr algn="l">
-              <a:spcAft>
-                <a:spcPts val="0"/>
-              </a:spcAft>
-            </a:pPr>
-            <a:r>
-              <a:rPr sz="1152" b="0" i="0">
-                <a:solidFill>
-                  <a:srgbClr val="E7F0F3"/>
-                </a:solidFill>
-                <a:latin typeface="Arial"/>
-              </a:rPr>
-              <a:t>• λθ = λφ = r/r₀</a:t>
-            </a:r>
-          </a:p>
-        </p:txBody>
-      </p:sp>
-      <p:sp>
-        <p:nvSpPr>
-          <p:cNvPr id="30" name="text 28" descr="sci-ppt:obj-028"/>
-          <p:cNvSpPr txBox="1"/>
-          <p:nvPr/>
-        </p:nvSpPr>
-        <p:spPr>
-          <a:xfrm>
-            <a:off x="365760" y="4864608"/>
-            <a:ext cx="8412480" cy="310896"/>
-          </a:xfrm>
-          <a:prstGeom prst="rect">
-            <a:avLst/>
-          </a:prstGeom>
-          <a:noFill/>
-          <a:effectLst/>
-        </p:spPr>
-        <p:txBody>
-          <a:bodyPr wrap="none" lIns="0" rIns="0" tIns="0" bIns="0" anchor="ctr">
-            <a:spAutoFit/>
-          </a:bodyPr>
-          <a:lstStyle/>
-          <a:p>
-            <a:pPr algn="l">
-              <a:spcAft>
-                <a:spcPts val="0"/>
-              </a:spcAft>
-            </a:pPr>
-            <a:r>
-              <a:rPr sz="1152" b="0" i="0">
-                <a:solidFill>
-                  <a:srgbClr val="E7F0F3"/>
-                </a:solidFill>
-                <a:latin typeface="Arial"/>
-              </a:rPr>
-              <a:t>Network material volume is unchanged</a:t>
-            </a:r>
-          </a:p>
-        </p:txBody>
-      </p:sp>
-      <p:sp>
-        <p:nvSpPr>
-          <p:cNvPr id="31" name="text 29" descr="sci-ppt:obj-029"/>
-          <p:cNvSpPr txBox="1"/>
-          <p:nvPr/>
-        </p:nvSpPr>
-        <p:spPr>
-          <a:xfrm>
-            <a:off x="365760" y="5074920"/>
-            <a:ext cx="8412480" cy="310896"/>
-          </a:xfrm>
-          <a:prstGeom prst="rect">
-            <a:avLst/>
-          </a:prstGeom>
-          <a:noFill/>
-          <a:effectLst/>
-        </p:spPr>
-        <p:txBody>
-          <a:bodyPr wrap="none" lIns="0" rIns="0" tIns="0" bIns="0" anchor="ctr">
-            <a:spAutoFit/>
-          </a:bodyPr>
-          <a:lstStyle/>
-          <a:p>
-            <a:pPr algn="l">
-              <a:spcAft>
-                <a:spcPts val="0"/>
-              </a:spcAft>
-            </a:pPr>
-            <a:r>
-              <a:rPr sz="1152" b="0" i="0">
-                <a:solidFill>
-                  <a:srgbClr val="E7F0F3"/>
-                </a:solidFill>
-                <a:latin typeface="Arial"/>
-              </a:rPr>
-              <a:t>Radial direction points outward</a:t>
+              <a:t>Exact incompressible kinematics of Eq. A-E01 for R_ref = 5 µm, R = 30 µm.</a:t>
             </a:r>
           </a:p>
         </p:txBody>

</xml_diff>